<commit_message>
Add file via Git
</commit_message>
<xml_diff>
--- a/自我介紹_優化版.pptx
+++ b/自我介紹_優化版.pptx
@@ -16,7 +16,7 @@
     <p:sldId id="260" r:id="rId7"/>
     <p:sldId id="414" r:id="rId8"/>
     <p:sldId id="261" r:id="rId9"/>
-    <p:sldId id="262" r:id="rId10"/>
+    <p:sldId id="415" r:id="rId10"/>
     <p:sldId id="263" r:id="rId11"/>
     <p:sldId id="264" r:id="rId12"/>
   </p:sldIdLst>
@@ -117,6 +117,11 @@
       </a:defRPr>
     </a:lvl9pPr>
   </p:defaultTextStyle>
+  <p:extLst>
+    <p:ext uri="{EFAFB233-063F-42B5-8137-9DF3F51BA10A}">
+      <p15:sldGuideLst xmlns:p15="http://schemas.microsoft.com/office/powerpoint/2012/main"/>
+    </p:ext>
+  </p:extLst>
 </p:presentation>
 </file>
 
@@ -2619,7 +2624,7 @@
           <a:p>
             <a:fld id="{6D4B1069-3899-470A-8AB1-734237277644}" type="datetimeFigureOut">
               <a:rPr lang="zh-CN" altLang="en-US" smtClean="0"/>
-              <a:t>2026/8/24</a:t>
+              <a:t>2026/8/25</a:t>
             </a:fld>
             <a:endParaRPr lang="zh-CN" altLang="en-US"/>
           </a:p>
@@ -35821,8 +35826,8 @@
         </p:nvSpPr>
         <p:spPr>
           <a:xfrm>
-            <a:off x="640080" y="329184"/>
-            <a:ext cx="2377440" cy="274320"/>
+            <a:off x="365760" y="146304"/>
+            <a:ext cx="3657600" cy="256032"/>
           </a:xfrm>
           <a:prstGeom prst="rect">
             <a:avLst/>
@@ -35830,16 +35835,16 @@
           <a:noFill/>
         </p:spPr>
         <p:txBody>
-          <a:bodyPr wrap="square" lIns="36576" tIns="36576" rIns="36576" bIns="36576" anchor="t">
+          <a:bodyPr wrap="square" lIns="45720" tIns="18288" rIns="45720" bIns="18288" anchor="ctr">
             <a:spAutoFit/>
           </a:bodyPr>
           <a:lstStyle/>
           <a:p>
             <a:pPr algn="l"/>
             <a:r>
-              <a:rPr sz="1550" b="1">
-                <a:solidFill>
-                  <a:srgbClr val="295BAA"/>
+              <a:rPr sz="1500" b="1">
+                <a:solidFill>
+                  <a:srgbClr val="2375D6"/>
                 </a:solidFill>
                 <a:latin typeface="Microsoft JhengHei"/>
               </a:rPr>
@@ -35856,8 +35861,8 @@
         </p:nvSpPr>
         <p:spPr>
           <a:xfrm>
-            <a:off x="640080" y="676656"/>
-            <a:ext cx="10881360" cy="438912"/>
+            <a:off x="365760" y="402336"/>
+            <a:ext cx="5943600" cy="438912"/>
           </a:xfrm>
           <a:prstGeom prst="rect">
             <a:avLst/>
@@ -35865,20 +35870,20 @@
           <a:noFill/>
         </p:spPr>
         <p:txBody>
-          <a:bodyPr wrap="square" lIns="36576" tIns="36576" rIns="36576" bIns="36576" anchor="t">
+          <a:bodyPr wrap="square" lIns="45720" tIns="18288" rIns="45720" bIns="18288" anchor="ctr">
             <a:spAutoFit/>
           </a:bodyPr>
           <a:lstStyle/>
           <a:p>
             <a:pPr algn="l"/>
             <a:r>
-              <a:rPr sz="2450" b="1">
-                <a:solidFill>
-                  <a:srgbClr val="22262D"/>
+              <a:rPr sz="2500" b="1">
+                <a:solidFill>
+                  <a:srgbClr val="191919"/>
                 </a:solidFill>
                 <a:latin typeface="Microsoft JhengHei"/>
               </a:rPr>
-              <a:t>05｜DevOps 與平台建置</a:t>
+              <a:t>DevOps 與平台建置</a:t>
             </a:r>
           </a:p>
         </p:txBody>
@@ -35891,8 +35896,8 @@
         </p:nvSpPr>
         <p:spPr>
           <a:xfrm>
-            <a:off x="640080" y="1133856"/>
-            <a:ext cx="10789920" cy="310896"/>
+            <a:off x="365760" y="832104"/>
+            <a:ext cx="8686800" cy="256032"/>
           </a:xfrm>
           <a:prstGeom prst="rect">
             <a:avLst/>
@@ -35900,1559 +35905,1638 @@
           <a:noFill/>
         </p:spPr>
         <p:txBody>
-          <a:bodyPr wrap="square" lIns="36576" tIns="36576" rIns="36576" bIns="36576" anchor="t">
+          <a:bodyPr wrap="square" lIns="45720" tIns="18288" rIns="45720" bIns="18288" anchor="ctr">
             <a:spAutoFit/>
           </a:bodyPr>
           <a:lstStyle/>
           <a:p>
             <a:pPr algn="l"/>
             <a:r>
-              <a:rPr sz="1350" b="0">
-                <a:solidFill>
-                  <a:srgbClr val="606874"/>
+              <a:rPr sz="1100" b="0" dirty="0" err="1">
+                <a:solidFill>
+                  <a:srgbClr val="696E78"/>
                 </a:solidFill>
                 <a:latin typeface="Microsoft JhengHei"/>
               </a:rPr>
-              <a:t>從程式碼品質、部署、監控到 MLOps，串起 GitLab CI/CD 與平台可觀測性</a:t>
+              <a:t>串接</a:t>
             </a:r>
-          </a:p>
-        </p:txBody>
-      </p:sp>
-      <p:sp>
-        <p:nvSpPr>
-          <p:cNvPr id="5" name="Rounded Rectangle 4"/>
-          <p:cNvSpPr/>
-          <p:nvPr/>
-        </p:nvSpPr>
-        <p:spPr>
-          <a:xfrm>
-            <a:off x="640080" y="1572768"/>
-            <a:ext cx="841248" cy="292608"/>
-          </a:xfrm>
-          <a:prstGeom prst="roundRect">
-            <a:avLst/>
-          </a:prstGeom>
-          <a:solidFill>
-            <a:srgbClr val="EEF4FC"/>
-          </a:solidFill>
-          <a:ln w="12700">
-            <a:solidFill>
-              <a:srgbClr val="EEF4FC"/>
-            </a:solidFill>
-          </a:ln>
-        </p:spPr>
-        <p:style>
-          <a:lnRef idx="1">
-            <a:schemeClr val="accent1"/>
-          </a:lnRef>
-          <a:fillRef idx="3">
-            <a:schemeClr val="accent1"/>
-          </a:fillRef>
-          <a:effectRef idx="2">
-            <a:schemeClr val="accent1"/>
-          </a:effectRef>
-          <a:fontRef idx="minor">
-            <a:schemeClr val="lt1"/>
-          </a:fontRef>
-        </p:style>
-        <p:txBody>
-          <a:bodyPr rtlCol="0" anchor="ctr"/>
-          <a:lstStyle/>
-          <a:p>
-            <a:pPr algn="ctr"/>
-            <a:endParaRPr/>
-          </a:p>
-        </p:txBody>
-      </p:sp>
-      <p:sp>
-        <p:nvSpPr>
-          <p:cNvPr id="6" name="TextBox 5"/>
-          <p:cNvSpPr txBox="1"/>
-          <p:nvPr/>
-        </p:nvSpPr>
-        <p:spPr>
-          <a:xfrm>
-            <a:off x="640080" y="1581912"/>
-            <a:ext cx="841248" cy="256032"/>
-          </a:xfrm>
-          <a:prstGeom prst="rect">
-            <a:avLst/>
-          </a:prstGeom>
-          <a:noFill/>
-        </p:spPr>
-        <p:txBody>
-          <a:bodyPr wrap="square" lIns="9144" tIns="9144" rIns="9144" bIns="9144" anchor="ctr">
-            <a:spAutoFit/>
-          </a:bodyPr>
-          <a:lstStyle/>
-          <a:p>
-            <a:pPr algn="ctr"/>
             <a:r>
-              <a:rPr sz="1050" b="1">
-                <a:solidFill>
-                  <a:srgbClr val="295BAA"/>
+              <a:rPr sz="1100" b="0" dirty="0">
+                <a:solidFill>
+                  <a:srgbClr val="696E78"/>
                 </a:solidFill>
                 <a:latin typeface="Microsoft JhengHei"/>
               </a:rPr>
-              <a:t>PROJECT 05</a:t>
+              <a:t> GitLab CI/</a:t>
             </a:r>
-          </a:p>
-        </p:txBody>
-      </p:sp>
-      <p:sp>
-        <p:nvSpPr>
-          <p:cNvPr id="7" name="Rounded Rectangle 6"/>
-          <p:cNvSpPr/>
-          <p:nvPr/>
-        </p:nvSpPr>
-        <p:spPr>
-          <a:xfrm>
-            <a:off x="1572768" y="1572768"/>
-            <a:ext cx="1005840" cy="292608"/>
-          </a:xfrm>
-          <a:prstGeom prst="roundRect">
-            <a:avLst/>
-          </a:prstGeom>
-          <a:solidFill>
-            <a:srgbClr val="EEF4FC"/>
-          </a:solidFill>
-          <a:ln w="12700">
-            <a:solidFill>
-              <a:srgbClr val="EEF4FC"/>
-            </a:solidFill>
-          </a:ln>
-        </p:spPr>
-        <p:style>
-          <a:lnRef idx="1">
-            <a:schemeClr val="accent1"/>
-          </a:lnRef>
-          <a:fillRef idx="3">
-            <a:schemeClr val="accent1"/>
-          </a:fillRef>
-          <a:effectRef idx="2">
-            <a:schemeClr val="accent1"/>
-          </a:effectRef>
-          <a:fontRef idx="minor">
-            <a:schemeClr val="lt1"/>
-          </a:fontRef>
-        </p:style>
-        <p:txBody>
-          <a:bodyPr rtlCol="0" anchor="ctr"/>
-          <a:lstStyle/>
-          <a:p>
-            <a:pPr algn="ctr"/>
-            <a:endParaRPr/>
-          </a:p>
-        </p:txBody>
-      </p:sp>
-      <p:sp>
-        <p:nvSpPr>
-          <p:cNvPr id="8" name="TextBox 7"/>
-          <p:cNvSpPr txBox="1"/>
-          <p:nvPr/>
-        </p:nvSpPr>
-        <p:spPr>
-          <a:xfrm>
-            <a:off x="1572768" y="1581912"/>
-            <a:ext cx="1005840" cy="256032"/>
-          </a:xfrm>
-          <a:prstGeom prst="rect">
-            <a:avLst/>
-          </a:prstGeom>
-          <a:noFill/>
-        </p:spPr>
-        <p:txBody>
-          <a:bodyPr wrap="square" lIns="9144" tIns="9144" rIns="9144" bIns="9144" anchor="ctr">
-            <a:spAutoFit/>
-          </a:bodyPr>
-          <a:lstStyle/>
-          <a:p>
-            <a:pPr algn="ctr"/>
             <a:r>
-              <a:rPr sz="1050" b="1">
-                <a:solidFill>
-                  <a:srgbClr val="295BAA"/>
+              <a:rPr sz="1100" b="0" dirty="0" err="1">
+                <a:solidFill>
+                  <a:srgbClr val="696E78"/>
                 </a:solidFill>
                 <a:latin typeface="Microsoft JhengHei"/>
               </a:rPr>
-              <a:t>DEVOPS</a:t>
+              <a:t>CD、部署自動化、監控平台與</a:t>
             </a:r>
-          </a:p>
-        </p:txBody>
-      </p:sp>
-      <p:sp>
-        <p:nvSpPr>
-          <p:cNvPr id="9" name="Rounded Rectangle 8"/>
-          <p:cNvSpPr/>
-          <p:nvPr/>
-        </p:nvSpPr>
-        <p:spPr>
-          <a:xfrm>
-            <a:off x="658368" y="2084831"/>
-            <a:ext cx="2578608" cy="2331720"/>
-          </a:xfrm>
-          <a:prstGeom prst="roundRect">
-            <a:avLst/>
-          </a:prstGeom>
-          <a:solidFill>
-            <a:srgbClr val="FFFFFF"/>
-          </a:solidFill>
-          <a:ln w="12700">
-            <a:solidFill>
-              <a:srgbClr val="295BAA"/>
-            </a:solidFill>
-          </a:ln>
-        </p:spPr>
-        <p:style>
-          <a:lnRef idx="1">
-            <a:schemeClr val="accent1"/>
-          </a:lnRef>
-          <a:fillRef idx="3">
-            <a:schemeClr val="accent1"/>
-          </a:fillRef>
-          <a:effectRef idx="2">
-            <a:schemeClr val="accent1"/>
-          </a:effectRef>
-          <a:fontRef idx="minor">
-            <a:schemeClr val="lt1"/>
-          </a:fontRef>
-        </p:style>
-        <p:txBody>
-          <a:bodyPr rtlCol="0" anchor="ctr"/>
-          <a:lstStyle/>
-          <a:p>
-            <a:pPr algn="ctr"/>
-            <a:endParaRPr/>
-          </a:p>
-        </p:txBody>
-      </p:sp>
-      <p:sp>
-        <p:nvSpPr>
-          <p:cNvPr id="10" name="Rounded Rectangle 9"/>
-          <p:cNvSpPr/>
-          <p:nvPr/>
-        </p:nvSpPr>
-        <p:spPr>
-          <a:xfrm>
-            <a:off x="822959" y="2249424"/>
-            <a:ext cx="749808" cy="292608"/>
-          </a:xfrm>
-          <a:prstGeom prst="roundRect">
-            <a:avLst/>
-          </a:prstGeom>
-          <a:solidFill>
-            <a:srgbClr val="295BAA"/>
-          </a:solidFill>
-          <a:ln w="12700">
-            <a:solidFill>
-              <a:srgbClr val="295BAA"/>
-            </a:solidFill>
-          </a:ln>
-        </p:spPr>
-        <p:style>
-          <a:lnRef idx="1">
-            <a:schemeClr val="accent1"/>
-          </a:lnRef>
-          <a:fillRef idx="3">
-            <a:schemeClr val="accent1"/>
-          </a:fillRef>
-          <a:effectRef idx="2">
-            <a:schemeClr val="accent1"/>
-          </a:effectRef>
-          <a:fontRef idx="minor">
-            <a:schemeClr val="lt1"/>
-          </a:fontRef>
-        </p:style>
-        <p:txBody>
-          <a:bodyPr rtlCol="0" anchor="ctr"/>
-          <a:lstStyle/>
-          <a:p>
-            <a:pPr algn="ctr"/>
-            <a:endParaRPr/>
-          </a:p>
-        </p:txBody>
-      </p:sp>
-      <p:sp>
-        <p:nvSpPr>
-          <p:cNvPr id="11" name="TextBox 10"/>
-          <p:cNvSpPr txBox="1"/>
-          <p:nvPr/>
-        </p:nvSpPr>
-        <p:spPr>
-          <a:xfrm>
-            <a:off x="822959" y="2258568"/>
-            <a:ext cx="749808" cy="256032"/>
-          </a:xfrm>
-          <a:prstGeom prst="rect">
-            <a:avLst/>
-          </a:prstGeom>
-          <a:noFill/>
-        </p:spPr>
-        <p:txBody>
-          <a:bodyPr wrap="square" lIns="9144" tIns="9144" rIns="9144" bIns="9144" anchor="ctr">
-            <a:spAutoFit/>
-          </a:bodyPr>
-          <a:lstStyle/>
-          <a:p>
-            <a:pPr algn="ctr"/>
             <a:r>
-              <a:rPr sz="1050" b="1">
-                <a:solidFill>
-                  <a:srgbClr val="FFFFFF"/>
+              <a:rPr sz="1100" b="0" dirty="0">
+                <a:solidFill>
+                  <a:srgbClr val="696E78"/>
                 </a:solidFill>
                 <a:latin typeface="Microsoft JhengHei"/>
               </a:rPr>
-              <a:t>TEST</a:t>
+              <a:t> </a:t>
             </a:r>
-          </a:p>
-        </p:txBody>
-      </p:sp>
-      <p:sp>
-        <p:nvSpPr>
-          <p:cNvPr id="12" name="TextBox 11"/>
-          <p:cNvSpPr txBox="1"/>
-          <p:nvPr/>
-        </p:nvSpPr>
-        <p:spPr>
-          <a:xfrm>
-            <a:off x="822959" y="2679191"/>
-            <a:ext cx="2249424" cy="502920"/>
-          </a:xfrm>
-          <a:prstGeom prst="rect">
-            <a:avLst/>
-          </a:prstGeom>
-          <a:noFill/>
-        </p:spPr>
-        <p:txBody>
-          <a:bodyPr wrap="square" lIns="36576" tIns="36576" rIns="36576" bIns="36576" anchor="t">
-            <a:spAutoFit/>
-          </a:bodyPr>
-          <a:lstStyle/>
-          <a:p>
-            <a:pPr algn="l"/>
             <a:r>
-              <a:rPr sz="1630" b="1">
-                <a:solidFill>
-                  <a:srgbClr val="22262D"/>
+              <a:rPr sz="1100" b="0" dirty="0" err="1">
+                <a:solidFill>
+                  <a:srgbClr val="696E78"/>
                 </a:solidFill>
                 <a:latin typeface="Microsoft JhengHei"/>
               </a:rPr>
-              <a:t>SonarQube × GitLab CI</a:t>
+              <a:t>MLOps，建立端到端交付流程</a:t>
             </a:r>
-          </a:p>
-        </p:txBody>
-      </p:sp>
-      <p:sp>
-        <p:nvSpPr>
-          <p:cNvPr id="13" name="TextBox 12"/>
-          <p:cNvSpPr txBox="1"/>
-          <p:nvPr/>
-        </p:nvSpPr>
-        <p:spPr>
-          <a:xfrm>
-            <a:off x="822959" y="3310128"/>
-            <a:ext cx="2231136" cy="777240"/>
+            <a:endParaRPr sz="1100" b="0" dirty="0">
+              <a:solidFill>
+                <a:srgbClr val="696E78"/>
+              </a:solidFill>
+              <a:latin typeface="Microsoft JhengHei"/>
+            </a:endParaRPr>
+          </a:p>
+        </p:txBody>
+      </p:sp>
+      <p:grpSp>
+        <p:nvGrpSpPr>
+          <p:cNvPr id="1025" name="群組 1024">
+            <a:extLst>
+              <a:ext uri="{FF2B5EF4-FFF2-40B4-BE49-F238E27FC236}">
+                <a16:creationId xmlns:a16="http://schemas.microsoft.com/office/drawing/2014/main" id="{D9EDB322-9AC9-0AB9-AED1-A29E22B933B8}"/>
+              </a:ext>
+            </a:extLst>
+          </p:cNvPr>
+          <p:cNvGrpSpPr/>
+          <p:nvPr/>
+        </p:nvGrpSpPr>
+        <p:grpSpPr>
+          <a:xfrm>
+            <a:off x="7955280" y="3593409"/>
+            <a:ext cx="3585136" cy="2237426"/>
+            <a:chOff x="8302064" y="2761488"/>
+            <a:chExt cx="3585136" cy="2237426"/>
+          </a:xfrm>
+        </p:grpSpPr>
+        <p:sp>
+          <p:nvSpPr>
+            <p:cNvPr id="24" name="Rounded Rectangle 23"/>
+            <p:cNvSpPr/>
+            <p:nvPr/>
+          </p:nvSpPr>
+          <p:spPr>
+            <a:xfrm>
+              <a:off x="9528048" y="2761488"/>
+              <a:ext cx="2359152" cy="2237426"/>
+            </a:xfrm>
+            <a:prstGeom prst="roundRect">
+              <a:avLst/>
+            </a:prstGeom>
+            <a:solidFill>
+              <a:srgbClr val="FFFFFF"/>
+            </a:solidFill>
+            <a:ln w="12700">
+              <a:solidFill>
+                <a:srgbClr val="188FEF"/>
+              </a:solidFill>
+            </a:ln>
+          </p:spPr>
+          <p:style>
+            <a:lnRef idx="1">
+              <a:schemeClr val="accent1"/>
+            </a:lnRef>
+            <a:fillRef idx="3">
+              <a:schemeClr val="accent1"/>
+            </a:fillRef>
+            <a:effectRef idx="2">
+              <a:schemeClr val="accent1"/>
+            </a:effectRef>
+            <a:fontRef idx="minor">
+              <a:schemeClr val="lt1"/>
+            </a:fontRef>
+          </p:style>
+          <p:txBody>
+            <a:bodyPr rtlCol="0" anchor="ctr"/>
+            <a:lstStyle/>
+            <a:p>
+              <a:pPr algn="ctr"/>
+              <a:endParaRPr/>
+            </a:p>
+          </p:txBody>
+        </p:sp>
+        <p:sp>
+          <p:nvSpPr>
+            <p:cNvPr id="26" name="TextBox 25"/>
+            <p:cNvSpPr txBox="1"/>
+            <p:nvPr/>
+          </p:nvSpPr>
+          <p:spPr>
+            <a:xfrm>
+              <a:off x="9709835" y="2933684"/>
+              <a:ext cx="1673352" cy="252377"/>
+            </a:xfrm>
+            <a:prstGeom prst="rect">
+              <a:avLst/>
+            </a:prstGeom>
+            <a:noFill/>
+          </p:spPr>
+          <p:txBody>
+            <a:bodyPr wrap="square" lIns="45720" tIns="18288" rIns="45720" bIns="18288" anchor="ctr">
+              <a:spAutoFit/>
+            </a:bodyPr>
+            <a:lstStyle>
+              <a:defPPr>
+                <a:defRPr lang="en-US"/>
+              </a:defPPr>
+              <a:lvl1pPr>
+                <a:defRPr sz="1400" b="1">
+                  <a:solidFill>
+                    <a:srgbClr val="2375D6"/>
+                  </a:solidFill>
+                  <a:latin typeface="Microsoft JhengHei"/>
+                </a:defRPr>
+              </a:lvl1pPr>
+            </a:lstStyle>
+            <a:p>
+              <a:r>
+                <a:rPr dirty="0"/>
+                <a:t>③ MONITOR </a:t>
+              </a:r>
+              <a:r>
+                <a:rPr dirty="0" err="1"/>
+                <a:t>階段</a:t>
+              </a:r>
+              <a:endParaRPr dirty="0"/>
+            </a:p>
+          </p:txBody>
+        </p:sp>
+        <p:sp>
+          <p:nvSpPr>
+            <p:cNvPr id="27" name="TextBox 26"/>
+            <p:cNvSpPr txBox="1"/>
+            <p:nvPr/>
+          </p:nvSpPr>
+          <p:spPr>
+            <a:xfrm>
+              <a:off x="9692640" y="3280914"/>
+              <a:ext cx="2029968" cy="1494705"/>
+            </a:xfrm>
+            <a:prstGeom prst="rect">
+              <a:avLst/>
+            </a:prstGeom>
+            <a:noFill/>
+          </p:spPr>
+          <p:txBody>
+            <a:bodyPr wrap="square">
+              <a:spAutoFit/>
+            </a:bodyPr>
+            <a:lstStyle>
+              <a:defPPr>
+                <a:defRPr lang="en-US"/>
+              </a:defPPr>
+              <a:lvl1pPr marL="171450" indent="-171450">
+                <a:lnSpc>
+                  <a:spcPct val="150000"/>
+                </a:lnSpc>
+                <a:spcAft>
+                  <a:spcPts val="100"/>
+                </a:spcAft>
+                <a:buFont typeface="Arial" panose="020B0604020202020204" pitchFamily="34" charset="0"/>
+                <a:buChar char="•"/>
+                <a:defRPr sz="1200">
+                  <a:solidFill>
+                    <a:srgbClr val="191919"/>
+                  </a:solidFill>
+                  <a:latin typeface="Microsoft JhengHei"/>
+                </a:defRPr>
+              </a:lvl1pPr>
+            </a:lstStyle>
+            <a:p>
+              <a:r>
+                <a:rPr lang="zh-TW" altLang="en-US" dirty="0"/>
+                <a:t>監控指標 </a:t>
+              </a:r>
+              <a:r>
+                <a:rPr lang="en-US" altLang="zh-TW" dirty="0"/>
+                <a:t>(</a:t>
+              </a:r>
+              <a:r>
+                <a:rPr dirty="0"/>
+                <a:t>Prometheus</a:t>
+              </a:r>
+              <a:r>
+                <a:rPr lang="en-US" altLang="zh-TW" dirty="0"/>
+                <a:t>)</a:t>
+              </a:r>
+            </a:p>
+            <a:p>
+              <a:r>
+                <a:rPr lang="zh-TW" altLang="en-US" dirty="0"/>
+                <a:t>日誌收集 </a:t>
+              </a:r>
+              <a:r>
+                <a:rPr lang="en-US" altLang="zh-TW" dirty="0"/>
+                <a:t>(</a:t>
+              </a:r>
+              <a:r>
+                <a:rPr dirty="0"/>
+                <a:t>EFK</a:t>
+              </a:r>
+              <a:r>
+                <a:rPr lang="en-US" altLang="zh-TW" dirty="0"/>
+                <a:t>)</a:t>
+              </a:r>
+              <a:endParaRPr dirty="0"/>
+            </a:p>
+            <a:p>
+              <a:r>
+                <a:rPr lang="zh-TW" altLang="en-US" dirty="0"/>
+                <a:t>長期儲存 </a:t>
+              </a:r>
+              <a:r>
+                <a:rPr lang="en-US" altLang="zh-TW" dirty="0"/>
+                <a:t>(</a:t>
+              </a:r>
+              <a:r>
+                <a:rPr dirty="0"/>
+                <a:t>Thanos</a:t>
+              </a:r>
+              <a:r>
+                <a:rPr lang="en-US" altLang="zh-TW" dirty="0"/>
+                <a:t>)</a:t>
+              </a:r>
+              <a:r>
+                <a:rPr dirty="0"/>
+                <a:t> </a:t>
+              </a:r>
+              <a:endParaRPr lang="en-US" dirty="0"/>
+            </a:p>
+            <a:p>
+              <a:r>
+                <a:rPr lang="zh-TW" altLang="en-US" dirty="0"/>
+                <a:t>戰情室報表 </a:t>
+              </a:r>
+              <a:r>
+                <a:rPr lang="en-US" altLang="zh-TW" dirty="0"/>
+                <a:t>(</a:t>
+              </a:r>
+              <a:r>
+                <a:rPr dirty="0"/>
+                <a:t>Grafana</a:t>
+              </a:r>
+              <a:r>
+                <a:rPr lang="en-US" altLang="zh-TW" dirty="0"/>
+                <a:t>)</a:t>
+              </a:r>
+              <a:endParaRPr dirty="0"/>
+            </a:p>
+            <a:p>
+              <a:r>
+                <a:rPr dirty="0" err="1"/>
+                <a:t>VictoriaMetrics</a:t>
+              </a:r>
+              <a:r>
+                <a:rPr dirty="0"/>
+                <a:t> cluster</a:t>
+              </a:r>
+            </a:p>
+          </p:txBody>
+        </p:sp>
+        <p:cxnSp>
+          <p:nvCxnSpPr>
+            <p:cNvPr id="34" name="Connector 33"/>
+            <p:cNvCxnSpPr>
+              <a:cxnSpLocks/>
+            </p:cNvCxnSpPr>
+            <p:nvPr/>
+          </p:nvCxnSpPr>
+          <p:spPr>
+            <a:xfrm flipH="1">
+              <a:off x="8302064" y="3470091"/>
+              <a:ext cx="1225984" cy="0"/>
+            </a:xfrm>
+            <a:prstGeom prst="line">
+              <a:avLst/>
+            </a:prstGeom>
+            <a:ln w="19050">
+              <a:solidFill>
+                <a:srgbClr val="188FEF"/>
+              </a:solidFill>
+            </a:ln>
+          </p:spPr>
+          <p:style>
+            <a:lnRef idx="2">
+              <a:schemeClr val="accent1"/>
+            </a:lnRef>
+            <a:fillRef idx="0">
+              <a:schemeClr val="accent1"/>
+            </a:fillRef>
+            <a:effectRef idx="1">
+              <a:schemeClr val="accent1"/>
+            </a:effectRef>
+            <a:fontRef idx="minor">
+              <a:schemeClr val="tx1"/>
+            </a:fontRef>
+          </p:style>
+        </p:cxnSp>
+      </p:grpSp>
+      <p:grpSp>
+        <p:nvGrpSpPr>
+          <p:cNvPr id="1037" name="群組 1036">
+            <a:extLst>
+              <a:ext uri="{FF2B5EF4-FFF2-40B4-BE49-F238E27FC236}">
+                <a16:creationId xmlns:a16="http://schemas.microsoft.com/office/drawing/2014/main" id="{93D2DE50-9718-97BA-A94C-B0F6F51434EC}"/>
+              </a:ext>
+            </a:extLst>
+          </p:cNvPr>
+          <p:cNvGrpSpPr/>
+          <p:nvPr/>
+        </p:nvGrpSpPr>
+        <p:grpSpPr>
+          <a:xfrm>
+            <a:off x="292608" y="6236208"/>
+            <a:ext cx="11594592" cy="411480"/>
+            <a:chOff x="292608" y="6236208"/>
+            <a:chExt cx="11594592" cy="411480"/>
+          </a:xfrm>
+        </p:grpSpPr>
+        <p:sp>
+          <p:nvSpPr>
+            <p:cNvPr id="52" name="Rounded Rectangle 51"/>
+            <p:cNvSpPr/>
+            <p:nvPr/>
+          </p:nvSpPr>
+          <p:spPr>
+            <a:xfrm>
+              <a:off x="292608" y="6236208"/>
+              <a:ext cx="11594592" cy="411480"/>
+            </a:xfrm>
+            <a:prstGeom prst="roundRect">
+              <a:avLst/>
+            </a:prstGeom>
+            <a:solidFill>
+              <a:srgbClr val="FFFFFF"/>
+            </a:solidFill>
+            <a:ln w="12700">
+              <a:solidFill>
+                <a:srgbClr val="2A9D78"/>
+              </a:solidFill>
+            </a:ln>
+          </p:spPr>
+          <p:style>
+            <a:lnRef idx="1">
+              <a:schemeClr val="accent1"/>
+            </a:lnRef>
+            <a:fillRef idx="3">
+              <a:schemeClr val="accent1"/>
+            </a:fillRef>
+            <a:effectRef idx="2">
+              <a:schemeClr val="accent1"/>
+            </a:effectRef>
+            <a:fontRef idx="minor">
+              <a:schemeClr val="lt1"/>
+            </a:fontRef>
+          </p:style>
+          <p:txBody>
+            <a:bodyPr rtlCol="0" anchor="ctr"/>
+            <a:lstStyle/>
+            <a:p>
+              <a:pPr algn="ctr"/>
+              <a:endParaRPr/>
+            </a:p>
+          </p:txBody>
+        </p:sp>
+        <p:sp>
+          <p:nvSpPr>
+            <p:cNvPr id="53" name="TextBox 52"/>
+            <p:cNvSpPr txBox="1"/>
+            <p:nvPr/>
+          </p:nvSpPr>
+          <p:spPr>
+            <a:xfrm>
+              <a:off x="475488" y="6325578"/>
+              <a:ext cx="3246120" cy="228600"/>
+            </a:xfrm>
+            <a:prstGeom prst="rect">
+              <a:avLst/>
+            </a:prstGeom>
+            <a:noFill/>
+          </p:spPr>
+          <p:txBody>
+            <a:bodyPr wrap="square" lIns="45720" tIns="18288" rIns="45720" bIns="18288" anchor="ctr">
+              <a:spAutoFit/>
+            </a:bodyPr>
+            <a:lstStyle/>
+            <a:p>
+              <a:pPr algn="l"/>
+              <a:r>
+                <a:rPr sz="1200" b="1" dirty="0">
+                  <a:solidFill>
+                    <a:srgbClr val="2A9D78"/>
+                  </a:solidFill>
+                  <a:latin typeface="Microsoft JhengHei"/>
+                </a:rPr>
+                <a:t>⑤ </a:t>
+              </a:r>
+              <a:r>
+                <a:rPr sz="1200" b="1" dirty="0" err="1">
+                  <a:solidFill>
+                    <a:srgbClr val="2A9D78"/>
+                  </a:solidFill>
+                  <a:latin typeface="Microsoft JhengHei"/>
+                </a:rPr>
+                <a:t>協助智能排程應用課導入</a:t>
+              </a:r>
+              <a:r>
+                <a:rPr sz="1200" b="1" dirty="0">
+                  <a:solidFill>
+                    <a:srgbClr val="2A9D78"/>
+                  </a:solidFill>
+                  <a:latin typeface="Microsoft JhengHei"/>
+                </a:rPr>
+                <a:t> CICD </a:t>
+              </a:r>
+              <a:r>
+                <a:rPr sz="1200" b="1" dirty="0" err="1">
+                  <a:solidFill>
+                    <a:srgbClr val="2A9D78"/>
+                  </a:solidFill>
+                  <a:latin typeface="Microsoft JhengHei"/>
+                </a:rPr>
+                <a:t>流程</a:t>
+              </a:r>
+              <a:endParaRPr sz="1200" b="1" dirty="0">
+                <a:solidFill>
+                  <a:srgbClr val="2A9D78"/>
+                </a:solidFill>
+                <a:latin typeface="Microsoft JhengHei"/>
+              </a:endParaRPr>
+            </a:p>
+          </p:txBody>
+        </p:sp>
+        <p:sp>
+          <p:nvSpPr>
+            <p:cNvPr id="54" name="TextBox 53"/>
+            <p:cNvSpPr txBox="1"/>
+            <p:nvPr/>
+          </p:nvSpPr>
+          <p:spPr>
+            <a:xfrm>
+              <a:off x="3703320" y="6325578"/>
+              <a:ext cx="4251960" cy="228600"/>
+            </a:xfrm>
+            <a:prstGeom prst="rect">
+              <a:avLst/>
+            </a:prstGeom>
+            <a:noFill/>
+          </p:spPr>
+          <p:txBody>
+            <a:bodyPr wrap="square" lIns="45720" tIns="18288" rIns="45720" bIns="18288" anchor="ctr">
+              <a:spAutoFit/>
+            </a:bodyPr>
+            <a:lstStyle/>
+            <a:p>
+              <a:pPr algn="ctr"/>
+              <a:r>
+                <a:rPr sz="1200" b="0">
+                  <a:solidFill>
+                    <a:srgbClr val="191919"/>
+                  </a:solidFill>
+                  <a:latin typeface="Microsoft JhengHei"/>
+                </a:rPr>
+                <a:t>Pipeline 設計  →  自動化部署  →  硬體資源監控</a:t>
+              </a:r>
+            </a:p>
+          </p:txBody>
+        </p:sp>
+        <p:sp>
+          <p:nvSpPr>
+            <p:cNvPr id="55" name="TextBox 54"/>
+            <p:cNvSpPr txBox="1"/>
+            <p:nvPr/>
+          </p:nvSpPr>
+          <p:spPr>
+            <a:xfrm>
+              <a:off x="8028431" y="6325578"/>
+              <a:ext cx="3611880" cy="228600"/>
+            </a:xfrm>
+            <a:prstGeom prst="rect">
+              <a:avLst/>
+            </a:prstGeom>
+            <a:noFill/>
+          </p:spPr>
+          <p:txBody>
+            <a:bodyPr wrap="square" lIns="45720" tIns="18288" rIns="45720" bIns="18288" anchor="ctr">
+              <a:spAutoFit/>
+            </a:bodyPr>
+            <a:lstStyle/>
+            <a:p>
+              <a:pPr algn="ctr"/>
+              <a:r>
+                <a:rPr sz="1200" b="1">
+                  <a:solidFill>
+                    <a:srgbClr val="2A9D78"/>
+                  </a:solidFill>
+                  <a:latin typeface="Microsoft JhengHei"/>
+                </a:rPr>
+                <a:t>Grafana Dashboard</a:t>
+              </a:r>
+            </a:p>
+          </p:txBody>
+        </p:sp>
+      </p:grpSp>
+      <p:grpSp>
+        <p:nvGrpSpPr>
+          <p:cNvPr id="58" name="群組 57">
+            <a:extLst>
+              <a:ext uri="{FF2B5EF4-FFF2-40B4-BE49-F238E27FC236}">
+                <a16:creationId xmlns:a16="http://schemas.microsoft.com/office/drawing/2014/main" id="{29849AB8-CA72-48A1-FB95-44AFF6378016}"/>
+              </a:ext>
+            </a:extLst>
+          </p:cNvPr>
+          <p:cNvGrpSpPr/>
+          <p:nvPr/>
+        </p:nvGrpSpPr>
+        <p:grpSpPr>
+          <a:xfrm>
+            <a:off x="261088" y="3856554"/>
+            <a:ext cx="3442232" cy="2003744"/>
+            <a:chOff x="-229006" y="1481328"/>
+            <a:chExt cx="3442232" cy="2003744"/>
+          </a:xfrm>
+        </p:grpSpPr>
+        <p:sp>
+          <p:nvSpPr>
+            <p:cNvPr id="16" name="Rounded Rectangle 15"/>
+            <p:cNvSpPr/>
+            <p:nvPr/>
+          </p:nvSpPr>
+          <p:spPr>
+            <a:xfrm>
+              <a:off x="-229006" y="1481328"/>
+              <a:ext cx="2493605" cy="2003744"/>
+            </a:xfrm>
+            <a:prstGeom prst="roundRect">
+              <a:avLst/>
+            </a:prstGeom>
+            <a:solidFill>
+              <a:srgbClr val="FFFFFF"/>
+            </a:solidFill>
+            <a:ln w="12700">
+              <a:solidFill>
+                <a:srgbClr val="2375D6"/>
+              </a:solidFill>
+            </a:ln>
+          </p:spPr>
+          <p:style>
+            <a:lnRef idx="1">
+              <a:schemeClr val="accent1"/>
+            </a:lnRef>
+            <a:fillRef idx="3">
+              <a:schemeClr val="accent1"/>
+            </a:fillRef>
+            <a:effectRef idx="2">
+              <a:schemeClr val="accent1"/>
+            </a:effectRef>
+            <a:fontRef idx="minor">
+              <a:schemeClr val="lt1"/>
+            </a:fontRef>
+          </p:style>
+          <p:txBody>
+            <a:bodyPr rtlCol="0" anchor="ctr"/>
+            <a:lstStyle/>
+            <a:p>
+              <a:pPr algn="ctr"/>
+              <a:endParaRPr/>
+            </a:p>
+          </p:txBody>
+        </p:sp>
+        <p:sp>
+          <p:nvSpPr>
+            <p:cNvPr id="18" name="TextBox 17"/>
+            <p:cNvSpPr txBox="1"/>
+            <p:nvPr/>
+          </p:nvSpPr>
+          <p:spPr>
+            <a:xfrm>
+              <a:off x="0" y="1627867"/>
+              <a:ext cx="1545336" cy="252377"/>
+            </a:xfrm>
+            <a:prstGeom prst="rect">
+              <a:avLst/>
+            </a:prstGeom>
+            <a:noFill/>
+          </p:spPr>
+          <p:txBody>
+            <a:bodyPr wrap="square" lIns="45720" tIns="18288" rIns="45720" bIns="18288" anchor="ctr">
+              <a:spAutoFit/>
+            </a:bodyPr>
+            <a:lstStyle/>
+            <a:p>
+              <a:pPr algn="l"/>
+              <a:r>
+                <a:rPr sz="1400" b="1" dirty="0">
+                  <a:solidFill>
+                    <a:srgbClr val="2375D6"/>
+                  </a:solidFill>
+                  <a:latin typeface="Microsoft JhengHei"/>
+                </a:rPr>
+                <a:t>① TEST </a:t>
+              </a:r>
+              <a:r>
+                <a:rPr sz="1400" b="1" dirty="0" err="1">
+                  <a:solidFill>
+                    <a:srgbClr val="2375D6"/>
+                  </a:solidFill>
+                  <a:latin typeface="Microsoft JhengHei"/>
+                </a:rPr>
+                <a:t>階段</a:t>
+              </a:r>
+              <a:endParaRPr sz="1400" b="1" dirty="0">
+                <a:solidFill>
+                  <a:srgbClr val="2375D6"/>
+                </a:solidFill>
+                <a:latin typeface="Microsoft JhengHei"/>
+              </a:endParaRPr>
+            </a:p>
+          </p:txBody>
+        </p:sp>
+        <p:sp>
+          <p:nvSpPr>
+            <p:cNvPr id="19" name="TextBox 18"/>
+            <p:cNvSpPr txBox="1"/>
+            <p:nvPr/>
+          </p:nvSpPr>
+          <p:spPr>
+            <a:xfrm>
+              <a:off x="-97766" y="1920240"/>
+              <a:ext cx="2264894" cy="625236"/>
+            </a:xfrm>
+            <a:prstGeom prst="rect">
+              <a:avLst/>
+            </a:prstGeom>
+            <a:noFill/>
+          </p:spPr>
+          <p:txBody>
+            <a:bodyPr wrap="square">
+              <a:spAutoFit/>
+            </a:bodyPr>
+            <a:lstStyle/>
+            <a:p>
+              <a:pPr marL="171450" indent="-171450">
+                <a:lnSpc>
+                  <a:spcPct val="150000"/>
+                </a:lnSpc>
+                <a:spcAft>
+                  <a:spcPts val="100"/>
+                </a:spcAft>
+                <a:buFont typeface="Arial" panose="020B0604020202020204" pitchFamily="34" charset="0"/>
+                <a:buChar char="•"/>
+                <a:defRPr sz="960">
+                  <a:solidFill>
+                    <a:srgbClr val="191919"/>
+                  </a:solidFill>
+                  <a:latin typeface="Microsoft JhengHei"/>
+                </a:defRPr>
+              </a:pPr>
+              <a:r>
+                <a:rPr sz="1200" dirty="0"/>
+                <a:t>SonarQube </a:t>
+              </a:r>
+              <a:r>
+                <a:rPr sz="1200" dirty="0" err="1"/>
+                <a:t>串接</a:t>
+              </a:r>
+              <a:r>
+                <a:rPr sz="1200" dirty="0"/>
+                <a:t> GitLab CI</a:t>
+              </a:r>
+            </a:p>
+            <a:p>
+              <a:pPr marL="171450" indent="-171450">
+                <a:lnSpc>
+                  <a:spcPct val="150000"/>
+                </a:lnSpc>
+                <a:spcAft>
+                  <a:spcPts val="100"/>
+                </a:spcAft>
+                <a:buFont typeface="Arial" panose="020B0604020202020204" pitchFamily="34" charset="0"/>
+                <a:buChar char="•"/>
+                <a:defRPr sz="960">
+                  <a:solidFill>
+                    <a:srgbClr val="191919"/>
+                  </a:solidFill>
+                  <a:latin typeface="Microsoft JhengHei"/>
+                </a:defRPr>
+              </a:pPr>
+              <a:r>
+                <a:rPr sz="1200" dirty="0" err="1"/>
+                <a:t>程式碼掃描與品質檢查</a:t>
+              </a:r>
+              <a:endParaRPr sz="1200" dirty="0"/>
+            </a:p>
+          </p:txBody>
+        </p:sp>
+        <p:cxnSp>
+          <p:nvCxnSpPr>
+            <p:cNvPr id="32" name="Connector 31"/>
+            <p:cNvCxnSpPr>
+              <a:cxnSpLocks/>
+            </p:cNvCxnSpPr>
+            <p:nvPr/>
+          </p:nvCxnSpPr>
+          <p:spPr>
+            <a:xfrm>
+              <a:off x="2264599" y="2003742"/>
+              <a:ext cx="948627" cy="0"/>
+            </a:xfrm>
+            <a:prstGeom prst="line">
+              <a:avLst/>
+            </a:prstGeom>
+            <a:ln w="19050">
+              <a:solidFill>
+                <a:srgbClr val="2375D6"/>
+              </a:solidFill>
+            </a:ln>
+          </p:spPr>
+          <p:style>
+            <a:lnRef idx="2">
+              <a:schemeClr val="accent1"/>
+            </a:lnRef>
+            <a:fillRef idx="0">
+              <a:schemeClr val="accent1"/>
+            </a:fillRef>
+            <a:effectRef idx="1">
+              <a:schemeClr val="accent1"/>
+            </a:effectRef>
+            <a:fontRef idx="minor">
+              <a:schemeClr val="tx1"/>
+            </a:fontRef>
+          </p:style>
+        </p:cxnSp>
+        <p:pic>
+          <p:nvPicPr>
+            <p:cNvPr id="1028" name="Picture 4" descr="GitLab SCM - Opsera">
+              <a:extLst>
+                <a:ext uri="{FF2B5EF4-FFF2-40B4-BE49-F238E27FC236}">
+                  <a16:creationId xmlns:a16="http://schemas.microsoft.com/office/drawing/2014/main" id="{446DA517-4031-37B0-16DB-A898059B3B31}"/>
+                </a:ext>
+              </a:extLst>
+            </p:cNvPr>
+            <p:cNvPicPr>
+              <a:picLocks noChangeAspect="1" noChangeArrowheads="1"/>
+            </p:cNvPicPr>
+            <p:nvPr/>
+          </p:nvPicPr>
+          <p:blipFill>
+            <a:blip r:embed="rId2" cstate="print">
+              <a:extLst>
+                <a:ext uri="{28A0092B-C50C-407E-A947-70E740481C1C}">
+                  <a14:useLocalDpi xmlns:a14="http://schemas.microsoft.com/office/drawing/2010/main" val="0"/>
+                </a:ext>
+              </a:extLst>
+            </a:blip>
+            <a:srcRect/>
+            <a:stretch>
+              <a:fillRect/>
+            </a:stretch>
+          </p:blipFill>
+          <p:spPr bwMode="auto">
+            <a:xfrm>
+              <a:off x="-229005" y="2623688"/>
+              <a:ext cx="795877" cy="721399"/>
+            </a:xfrm>
+            <a:prstGeom prst="rect">
+              <a:avLst/>
+            </a:prstGeom>
+            <a:noFill/>
+            <a:extLst>
+              <a:ext uri="{909E8E84-426E-40DD-AFC4-6F175D3DCCD1}">
+                <a14:hiddenFill xmlns:a14="http://schemas.microsoft.com/office/drawing/2010/main">
+                  <a:solidFill>
+                    <a:srgbClr val="FFFFFF"/>
+                  </a:solidFill>
+                </a14:hiddenFill>
+              </a:ext>
+            </a:extLst>
+          </p:spPr>
+        </p:pic>
+        <p:cxnSp>
+          <p:nvCxnSpPr>
+            <p:cNvPr id="57" name="直線單箭頭接點 56">
+              <a:extLst>
+                <a:ext uri="{FF2B5EF4-FFF2-40B4-BE49-F238E27FC236}">
+                  <a16:creationId xmlns:a16="http://schemas.microsoft.com/office/drawing/2014/main" id="{6B008BD5-2BC6-80E6-D20B-3894E43E01F3}"/>
+                </a:ext>
+              </a:extLst>
+            </p:cNvPr>
+            <p:cNvCxnSpPr/>
+            <p:nvPr/>
+          </p:nvCxnSpPr>
+          <p:spPr>
+            <a:xfrm>
+              <a:off x="534608" y="2941277"/>
+              <a:ext cx="335826" cy="0"/>
+            </a:xfrm>
+            <a:prstGeom prst="straightConnector1">
+              <a:avLst/>
+            </a:prstGeom>
+            <a:ln w="28575">
+              <a:solidFill>
+                <a:schemeClr val="tx1">
+                  <a:lumMod val="50000"/>
+                  <a:lumOff val="50000"/>
+                </a:schemeClr>
+              </a:solidFill>
+              <a:tailEnd type="triangle"/>
+            </a:ln>
+          </p:spPr>
+          <p:style>
+            <a:lnRef idx="1">
+              <a:schemeClr val="dk1"/>
+            </a:lnRef>
+            <a:fillRef idx="0">
+              <a:schemeClr val="dk1"/>
+            </a:fillRef>
+            <a:effectRef idx="0">
+              <a:schemeClr val="dk1"/>
+            </a:effectRef>
+            <a:fontRef idx="minor">
+              <a:schemeClr val="tx1"/>
+            </a:fontRef>
+          </p:style>
+        </p:cxnSp>
+        <p:pic>
+          <p:nvPicPr>
+            <p:cNvPr id="1030" name="Picture 6" descr="SonarQube - Eclipsepedia">
+              <a:extLst>
+                <a:ext uri="{FF2B5EF4-FFF2-40B4-BE49-F238E27FC236}">
+                  <a16:creationId xmlns:a16="http://schemas.microsoft.com/office/drawing/2014/main" id="{963C25F2-F6DC-6D9E-E822-6D5D45326A5B}"/>
+                </a:ext>
+              </a:extLst>
+            </p:cNvPr>
+            <p:cNvPicPr>
+              <a:picLocks noChangeAspect="1" noChangeArrowheads="1"/>
+            </p:cNvPicPr>
+            <p:nvPr/>
+          </p:nvPicPr>
+          <p:blipFill>
+            <a:blip r:embed="rId3" cstate="print">
+              <a:extLst>
+                <a:ext uri="{28A0092B-C50C-407E-A947-70E740481C1C}">
+                  <a14:useLocalDpi xmlns:a14="http://schemas.microsoft.com/office/drawing/2010/main" val="0"/>
+                </a:ext>
+              </a:extLst>
+            </a:blip>
+            <a:srcRect/>
+            <a:stretch>
+              <a:fillRect/>
+            </a:stretch>
+          </p:blipFill>
+          <p:spPr bwMode="auto">
+            <a:xfrm>
+              <a:off x="1071116" y="2766764"/>
+              <a:ext cx="1004572" cy="263946"/>
+            </a:xfrm>
+            <a:prstGeom prst="rect">
+              <a:avLst/>
+            </a:prstGeom>
+            <a:noFill/>
+            <a:extLst>
+              <a:ext uri="{909E8E84-426E-40DD-AFC4-6F175D3DCCD1}">
+                <a14:hiddenFill xmlns:a14="http://schemas.microsoft.com/office/drawing/2010/main">
+                  <a:solidFill>
+                    <a:srgbClr val="FFFFFF"/>
+                  </a:solidFill>
+                </a14:hiddenFill>
+              </a:ext>
+            </a:extLst>
+          </p:spPr>
+        </p:pic>
+      </p:grpSp>
+      <p:grpSp>
+        <p:nvGrpSpPr>
+          <p:cNvPr id="1024" name="群組 1023">
+            <a:extLst>
+              <a:ext uri="{FF2B5EF4-FFF2-40B4-BE49-F238E27FC236}">
+                <a16:creationId xmlns:a16="http://schemas.microsoft.com/office/drawing/2014/main" id="{2B783948-7337-42B4-EAF3-87AE4DB7D287}"/>
+              </a:ext>
+            </a:extLst>
+          </p:cNvPr>
+          <p:cNvGrpSpPr/>
+          <p:nvPr/>
+        </p:nvGrpSpPr>
+        <p:grpSpPr>
+          <a:xfrm>
+            <a:off x="7706264" y="216958"/>
+            <a:ext cx="3440098" cy="1982938"/>
+            <a:chOff x="7613214" y="173666"/>
+            <a:chExt cx="3440098" cy="1982938"/>
+          </a:xfrm>
+        </p:grpSpPr>
+        <p:sp>
+          <p:nvSpPr>
+            <p:cNvPr id="20" name="Rounded Rectangle 19"/>
+            <p:cNvSpPr/>
+            <p:nvPr/>
+          </p:nvSpPr>
+          <p:spPr>
+            <a:xfrm>
+              <a:off x="8814815" y="173666"/>
+              <a:ext cx="2238497" cy="1982938"/>
+            </a:xfrm>
+            <a:prstGeom prst="roundRect">
+              <a:avLst/>
+            </a:prstGeom>
+            <a:solidFill>
+              <a:srgbClr val="FFFFFF"/>
+            </a:solidFill>
+            <a:ln w="12700">
+              <a:solidFill>
+                <a:srgbClr val="188FEF"/>
+              </a:solidFill>
+            </a:ln>
+          </p:spPr>
+          <p:style>
+            <a:lnRef idx="1">
+              <a:schemeClr val="accent1"/>
+            </a:lnRef>
+            <a:fillRef idx="3">
+              <a:schemeClr val="accent1"/>
+            </a:fillRef>
+            <a:effectRef idx="2">
+              <a:schemeClr val="accent1"/>
+            </a:effectRef>
+            <a:fontRef idx="minor">
+              <a:schemeClr val="lt1"/>
+            </a:fontRef>
+          </p:style>
+          <p:txBody>
+            <a:bodyPr rtlCol="0" anchor="ctr"/>
+            <a:lstStyle/>
+            <a:p>
+              <a:pPr algn="ctr"/>
+              <a:endParaRPr/>
+            </a:p>
+          </p:txBody>
+        </p:sp>
+        <p:sp>
+          <p:nvSpPr>
+            <p:cNvPr id="22" name="TextBox 21"/>
+            <p:cNvSpPr txBox="1"/>
+            <p:nvPr/>
+          </p:nvSpPr>
+          <p:spPr>
+            <a:xfrm>
+              <a:off x="9025128" y="276077"/>
+              <a:ext cx="1572768" cy="252377"/>
+            </a:xfrm>
+            <a:prstGeom prst="rect">
+              <a:avLst/>
+            </a:prstGeom>
+            <a:noFill/>
+          </p:spPr>
+          <p:txBody>
+            <a:bodyPr wrap="square" lIns="45720" tIns="18288" rIns="45720" bIns="18288" anchor="ctr">
+              <a:spAutoFit/>
+            </a:bodyPr>
+            <a:lstStyle>
+              <a:defPPr>
+                <a:defRPr lang="en-US"/>
+              </a:defPPr>
+              <a:lvl1pPr>
+                <a:defRPr sz="1400" b="1">
+                  <a:solidFill>
+                    <a:srgbClr val="2375D6"/>
+                  </a:solidFill>
+                  <a:latin typeface="Microsoft JhengHei"/>
+                </a:defRPr>
+              </a:lvl1pPr>
+            </a:lstStyle>
+            <a:p>
+              <a:r>
+                <a:rPr dirty="0"/>
+                <a:t>② DEPLOY </a:t>
+              </a:r>
+              <a:r>
+                <a:rPr dirty="0" err="1"/>
+                <a:t>階段</a:t>
+              </a:r>
+              <a:endParaRPr dirty="0"/>
+            </a:p>
+          </p:txBody>
+        </p:sp>
+        <p:sp>
+          <p:nvSpPr>
+            <p:cNvPr id="23" name="TextBox 22"/>
+            <p:cNvSpPr txBox="1"/>
+            <p:nvPr/>
+          </p:nvSpPr>
+          <p:spPr>
+            <a:xfrm>
+              <a:off x="8979408" y="612578"/>
+              <a:ext cx="1901952" cy="625236"/>
+            </a:xfrm>
+            <a:prstGeom prst="rect">
+              <a:avLst/>
+            </a:prstGeom>
+            <a:noFill/>
+          </p:spPr>
+          <p:txBody>
+            <a:bodyPr wrap="square">
+              <a:spAutoFit/>
+            </a:bodyPr>
+            <a:lstStyle>
+              <a:defPPr>
+                <a:defRPr lang="en-US"/>
+              </a:defPPr>
+              <a:lvl1pPr>
+                <a:lnSpc>
+                  <a:spcPct val="150000"/>
+                </a:lnSpc>
+                <a:spcAft>
+                  <a:spcPts val="100"/>
+                </a:spcAft>
+                <a:defRPr sz="1200">
+                  <a:solidFill>
+                    <a:srgbClr val="191919"/>
+                  </a:solidFill>
+                  <a:latin typeface="Microsoft JhengHei"/>
+                </a:defRPr>
+              </a:lvl1pPr>
+            </a:lstStyle>
+            <a:p>
+              <a:pPr marL="171450" indent="-171450">
+                <a:buFont typeface="Arial" panose="020B0604020202020204" pitchFamily="34" charset="0"/>
+                <a:buChar char="•"/>
+              </a:pPr>
+              <a:r>
+                <a:rPr dirty="0"/>
+                <a:t>Ansible </a:t>
+              </a:r>
+              <a:r>
+                <a:rPr dirty="0" err="1"/>
+                <a:t>自動化部署</a:t>
+              </a:r>
+              <a:endParaRPr dirty="0"/>
+            </a:p>
+            <a:p>
+              <a:pPr marL="171450" indent="-171450">
+                <a:buFont typeface="Arial" panose="020B0604020202020204" pitchFamily="34" charset="0"/>
+                <a:buChar char="•"/>
+              </a:pPr>
+              <a:r>
+                <a:rPr dirty="0" err="1"/>
+                <a:t>串接</a:t>
+              </a:r>
+              <a:r>
+                <a:rPr dirty="0"/>
+                <a:t> GitLab CD </a:t>
+              </a:r>
+              <a:r>
+                <a:rPr dirty="0" err="1"/>
+                <a:t>流程</a:t>
+              </a:r>
+              <a:endParaRPr dirty="0"/>
+            </a:p>
+          </p:txBody>
+        </p:sp>
+        <p:cxnSp>
+          <p:nvCxnSpPr>
+            <p:cNvPr id="33" name="Connector 32"/>
+            <p:cNvCxnSpPr>
+              <a:cxnSpLocks/>
+            </p:cNvCxnSpPr>
+            <p:nvPr/>
+          </p:nvCxnSpPr>
+          <p:spPr>
+            <a:xfrm flipH="1">
+              <a:off x="7613214" y="1403453"/>
+              <a:ext cx="1183314" cy="0"/>
+            </a:xfrm>
+            <a:prstGeom prst="line">
+              <a:avLst/>
+            </a:prstGeom>
+            <a:ln w="19050">
+              <a:solidFill>
+                <a:srgbClr val="188FEF"/>
+              </a:solidFill>
+            </a:ln>
+          </p:spPr>
+          <p:style>
+            <a:lnRef idx="2">
+              <a:schemeClr val="accent1"/>
+            </a:lnRef>
+            <a:fillRef idx="0">
+              <a:schemeClr val="accent1"/>
+            </a:fillRef>
+            <a:effectRef idx="1">
+              <a:schemeClr val="accent1"/>
+            </a:effectRef>
+            <a:fontRef idx="minor">
+              <a:schemeClr val="tx1"/>
+            </a:fontRef>
+          </p:style>
+        </p:cxnSp>
+        <p:pic>
+          <p:nvPicPr>
+            <p:cNvPr id="61" name="Picture 4" descr="GitLab SCM - Opsera">
+              <a:extLst>
+                <a:ext uri="{FF2B5EF4-FFF2-40B4-BE49-F238E27FC236}">
+                  <a16:creationId xmlns:a16="http://schemas.microsoft.com/office/drawing/2014/main" id="{870E659A-0192-2943-73C9-10A7D2453F41}"/>
+                </a:ext>
+              </a:extLst>
+            </p:cNvPr>
+            <p:cNvPicPr>
+              <a:picLocks noChangeAspect="1" noChangeArrowheads="1"/>
+            </p:cNvPicPr>
+            <p:nvPr/>
+          </p:nvPicPr>
+          <p:blipFill>
+            <a:blip r:embed="rId2" cstate="print">
+              <a:extLst>
+                <a:ext uri="{28A0092B-C50C-407E-A947-70E740481C1C}">
+                  <a14:useLocalDpi xmlns:a14="http://schemas.microsoft.com/office/drawing/2010/main" val="0"/>
+                </a:ext>
+              </a:extLst>
+            </a:blip>
+            <a:srcRect/>
+            <a:stretch>
+              <a:fillRect/>
+            </a:stretch>
+          </p:blipFill>
+          <p:spPr bwMode="auto">
+            <a:xfrm>
+              <a:off x="9930384" y="1267878"/>
+              <a:ext cx="795877" cy="721399"/>
+            </a:xfrm>
+            <a:prstGeom prst="rect">
+              <a:avLst/>
+            </a:prstGeom>
+            <a:noFill/>
+            <a:extLst>
+              <a:ext uri="{909E8E84-426E-40DD-AFC4-6F175D3DCCD1}">
+                <a14:hiddenFill xmlns:a14="http://schemas.microsoft.com/office/drawing/2010/main">
+                  <a:solidFill>
+                    <a:srgbClr val="FFFFFF"/>
+                  </a:solidFill>
+                </a14:hiddenFill>
+              </a:ext>
+            </a:extLst>
+          </p:spPr>
+        </p:pic>
+        <p:pic>
+          <p:nvPicPr>
+            <p:cNvPr id="1032" name="Picture 8">
+              <a:extLst>
+                <a:ext uri="{FF2B5EF4-FFF2-40B4-BE49-F238E27FC236}">
+                  <a16:creationId xmlns:a16="http://schemas.microsoft.com/office/drawing/2014/main" id="{38C2870C-E1D2-900C-9AE7-6A8AE8BF64E5}"/>
+                </a:ext>
+              </a:extLst>
+            </p:cNvPr>
+            <p:cNvPicPr>
+              <a:picLocks noChangeAspect="1" noChangeArrowheads="1"/>
+            </p:cNvPicPr>
+            <p:nvPr/>
+          </p:nvPicPr>
+          <p:blipFill>
+            <a:blip r:embed="rId4" cstate="print">
+              <a:extLst>
+                <a:ext uri="{28A0092B-C50C-407E-A947-70E740481C1C}">
+                  <a14:useLocalDpi xmlns:a14="http://schemas.microsoft.com/office/drawing/2010/main" val="0"/>
+                </a:ext>
+              </a:extLst>
+            </a:blip>
+            <a:srcRect/>
+            <a:stretch>
+              <a:fillRect/>
+            </a:stretch>
+          </p:blipFill>
+          <p:spPr bwMode="auto">
+            <a:xfrm>
+              <a:off x="9219437" y="1361671"/>
+              <a:ext cx="459039" cy="566148"/>
+            </a:xfrm>
+            <a:prstGeom prst="rect">
+              <a:avLst/>
+            </a:prstGeom>
+            <a:noFill/>
+            <a:extLst>
+              <a:ext uri="{909E8E84-426E-40DD-AFC4-6F175D3DCCD1}">
+                <a14:hiddenFill xmlns:a14="http://schemas.microsoft.com/office/drawing/2010/main">
+                  <a:solidFill>
+                    <a:srgbClr val="FFFFFF"/>
+                  </a:solidFill>
+                </a14:hiddenFill>
+              </a:ext>
+            </a:extLst>
+          </p:spPr>
+        </p:pic>
+      </p:grpSp>
+      <p:grpSp>
+        <p:nvGrpSpPr>
+          <p:cNvPr id="1035" name="群組 1034">
+            <a:extLst>
+              <a:ext uri="{FF2B5EF4-FFF2-40B4-BE49-F238E27FC236}">
+                <a16:creationId xmlns:a16="http://schemas.microsoft.com/office/drawing/2014/main" id="{53B201FD-9A6D-2003-1511-C6454F7D4487}"/>
+              </a:ext>
+            </a:extLst>
+          </p:cNvPr>
+          <p:cNvGrpSpPr/>
+          <p:nvPr/>
+        </p:nvGrpSpPr>
+        <p:grpSpPr>
+          <a:xfrm>
+            <a:off x="4590694" y="4555156"/>
+            <a:ext cx="2395728" cy="1478366"/>
+            <a:chOff x="4572000" y="4629826"/>
+            <a:chExt cx="2395728" cy="1478366"/>
+          </a:xfrm>
+        </p:grpSpPr>
+        <p:sp>
+          <p:nvSpPr>
+            <p:cNvPr id="28" name="Rounded Rectangle 27"/>
+            <p:cNvSpPr/>
+            <p:nvPr/>
+          </p:nvSpPr>
+          <p:spPr>
+            <a:xfrm>
+              <a:off x="4572000" y="4629826"/>
+              <a:ext cx="2395728" cy="1478366"/>
+            </a:xfrm>
+            <a:prstGeom prst="roundRect">
+              <a:avLst/>
+            </a:prstGeom>
+            <a:solidFill>
+              <a:srgbClr val="FFFFFF"/>
+            </a:solidFill>
+            <a:ln w="12700">
+              <a:solidFill>
+                <a:srgbClr val="7153B8"/>
+              </a:solidFill>
+            </a:ln>
+          </p:spPr>
+          <p:style>
+            <a:lnRef idx="1">
+              <a:schemeClr val="accent1"/>
+            </a:lnRef>
+            <a:fillRef idx="3">
+              <a:schemeClr val="accent1"/>
+            </a:fillRef>
+            <a:effectRef idx="2">
+              <a:schemeClr val="accent1"/>
+            </a:effectRef>
+            <a:fontRef idx="minor">
+              <a:schemeClr val="lt1"/>
+            </a:fontRef>
+          </p:style>
+          <p:txBody>
+            <a:bodyPr rtlCol="0" anchor="ctr"/>
+            <a:lstStyle/>
+            <a:p>
+              <a:pPr algn="ctr"/>
+              <a:endParaRPr/>
+            </a:p>
+          </p:txBody>
+        </p:sp>
+        <p:sp>
+          <p:nvSpPr>
+            <p:cNvPr id="30" name="TextBox 29"/>
+            <p:cNvSpPr txBox="1"/>
+            <p:nvPr/>
+          </p:nvSpPr>
+          <p:spPr>
+            <a:xfrm>
+              <a:off x="4688165" y="4732238"/>
+              <a:ext cx="2160691" cy="252377"/>
+            </a:xfrm>
+            <a:prstGeom prst="rect">
+              <a:avLst/>
+            </a:prstGeom>
+            <a:noFill/>
+          </p:spPr>
+          <p:txBody>
+            <a:bodyPr wrap="square" lIns="45720" tIns="18288" rIns="45720" bIns="18288" anchor="ctr">
+              <a:spAutoFit/>
+            </a:bodyPr>
+            <a:lstStyle/>
+            <a:p>
+              <a:pPr algn="l"/>
+              <a:r>
+                <a:rPr sz="1400" b="1" dirty="0">
+                  <a:solidFill>
+                    <a:srgbClr val="7153B8"/>
+                  </a:solidFill>
+                  <a:latin typeface="Microsoft JhengHei"/>
+                </a:rPr>
+                <a:t>④ </a:t>
+              </a:r>
+              <a:r>
+                <a:rPr sz="1400" b="1" dirty="0" err="1">
+                  <a:solidFill>
+                    <a:srgbClr val="7153B8"/>
+                  </a:solidFill>
+                  <a:latin typeface="Microsoft JhengHei"/>
+                </a:rPr>
+                <a:t>MLOps</a:t>
+              </a:r>
+              <a:r>
+                <a:rPr sz="1400" b="1" dirty="0">
+                  <a:solidFill>
+                    <a:srgbClr val="7153B8"/>
+                  </a:solidFill>
+                  <a:latin typeface="Microsoft JhengHei"/>
+                </a:rPr>
+                <a:t> </a:t>
+              </a:r>
+              <a:r>
+                <a:rPr lang="en-US" altLang="zh-TW" sz="1400" b="1" dirty="0">
+                  <a:solidFill>
+                    <a:srgbClr val="7153B8"/>
+                  </a:solidFill>
+                  <a:latin typeface="Microsoft JhengHei"/>
+                </a:rPr>
+                <a:t>TRAIN</a:t>
+              </a:r>
+              <a:r>
+                <a:rPr lang="zh-TW" altLang="en-US" sz="1400" b="1" dirty="0">
+                  <a:solidFill>
+                    <a:srgbClr val="7153B8"/>
+                  </a:solidFill>
+                  <a:latin typeface="Microsoft JhengHei"/>
+                </a:rPr>
+                <a:t> </a:t>
+              </a:r>
+              <a:r>
+                <a:rPr sz="1400" b="1" dirty="0" err="1">
+                  <a:solidFill>
+                    <a:srgbClr val="7153B8"/>
+                  </a:solidFill>
+                  <a:latin typeface="Microsoft JhengHei"/>
+                </a:rPr>
+                <a:t>階段</a:t>
+              </a:r>
+              <a:endParaRPr sz="1400" b="1" dirty="0">
+                <a:solidFill>
+                  <a:srgbClr val="7153B8"/>
+                </a:solidFill>
+                <a:latin typeface="Microsoft JhengHei"/>
+              </a:endParaRPr>
+            </a:p>
+          </p:txBody>
+        </p:sp>
+        <p:sp>
+          <p:nvSpPr>
+            <p:cNvPr id="1033" name="TextBox 26">
+              <a:extLst>
+                <a:ext uri="{FF2B5EF4-FFF2-40B4-BE49-F238E27FC236}">
+                  <a16:creationId xmlns:a16="http://schemas.microsoft.com/office/drawing/2014/main" id="{ED123DA1-D3A0-FB1B-CC03-3FEE1A6418F5}"/>
+                </a:ext>
+              </a:extLst>
+            </p:cNvPr>
+            <p:cNvSpPr txBox="1"/>
+            <p:nvPr/>
+          </p:nvSpPr>
+          <p:spPr>
+            <a:xfrm>
+              <a:off x="4709160" y="4970743"/>
+              <a:ext cx="2029968" cy="625236"/>
+            </a:xfrm>
+            <a:prstGeom prst="rect">
+              <a:avLst/>
+            </a:prstGeom>
+            <a:noFill/>
+          </p:spPr>
+          <p:txBody>
+            <a:bodyPr wrap="square">
+              <a:spAutoFit/>
+            </a:bodyPr>
+            <a:lstStyle>
+              <a:defPPr>
+                <a:defRPr lang="en-US"/>
+              </a:defPPr>
+              <a:lvl1pPr marL="171450" indent="-171450">
+                <a:lnSpc>
+                  <a:spcPct val="150000"/>
+                </a:lnSpc>
+                <a:spcAft>
+                  <a:spcPts val="100"/>
+                </a:spcAft>
+                <a:buFont typeface="Arial" panose="020B0604020202020204" pitchFamily="34" charset="0"/>
+                <a:buChar char="•"/>
+                <a:defRPr sz="1200">
+                  <a:solidFill>
+                    <a:srgbClr val="191919"/>
+                  </a:solidFill>
+                  <a:latin typeface="Microsoft JhengHei"/>
+                </a:defRPr>
+              </a:lvl1pPr>
+            </a:lstStyle>
+            <a:p>
+              <a:r>
+                <a:rPr lang="zh-TW" altLang="en-US" dirty="0"/>
+                <a:t>模型監控 </a:t>
+              </a:r>
+              <a:r>
+                <a:rPr lang="en-US" altLang="zh-TW" dirty="0"/>
+                <a:t>(</a:t>
+              </a:r>
+              <a:r>
+                <a:rPr lang="en-US" altLang="zh-TW" dirty="0" err="1"/>
+                <a:t>MLflow</a:t>
+              </a:r>
+              <a:r>
+                <a:rPr lang="en-US" altLang="zh-TW" dirty="0"/>
+                <a:t>)</a:t>
+              </a:r>
+            </a:p>
+            <a:p>
+              <a:r>
+                <a:rPr lang="zh-TW" altLang="en-US" dirty="0"/>
+                <a:t>資料版控 </a:t>
+              </a:r>
+              <a:r>
+                <a:rPr lang="en-US" altLang="zh-TW" dirty="0"/>
+                <a:t>(DVC)</a:t>
+              </a:r>
+              <a:endParaRPr dirty="0"/>
+            </a:p>
+          </p:txBody>
+        </p:sp>
+        <p:pic>
+          <p:nvPicPr>
+            <p:cNvPr id="1034" name="Picture 10" descr="A simple introduction to MLFlow. Some of you might have heard a… | by  Hitoruna | Medium">
+              <a:extLst>
+                <a:ext uri="{FF2B5EF4-FFF2-40B4-BE49-F238E27FC236}">
+                  <a16:creationId xmlns:a16="http://schemas.microsoft.com/office/drawing/2014/main" id="{AD635129-0CC1-39C8-3097-92606B8BB405}"/>
+                </a:ext>
+              </a:extLst>
+            </p:cNvPr>
+            <p:cNvPicPr>
+              <a:picLocks noChangeAspect="1" noChangeArrowheads="1"/>
+            </p:cNvPicPr>
+            <p:nvPr/>
+          </p:nvPicPr>
+          <p:blipFill>
+            <a:blip r:embed="rId5" cstate="print">
+              <a:clrChange>
+                <a:clrFrom>
+                  <a:srgbClr val="FFFFFF"/>
+                </a:clrFrom>
+                <a:clrTo>
+                  <a:srgbClr val="FFFFFF">
+                    <a:alpha val="0"/>
+                  </a:srgbClr>
+                </a:clrTo>
+              </a:clrChange>
+              <a:extLst>
+                <a:ext uri="{28A0092B-C50C-407E-A947-70E740481C1C}">
+                  <a14:useLocalDpi xmlns:a14="http://schemas.microsoft.com/office/drawing/2010/main" val="0"/>
+                </a:ext>
+              </a:extLst>
+            </a:blip>
+            <a:srcRect/>
+            <a:stretch>
+              <a:fillRect/>
+            </a:stretch>
+          </p:blipFill>
+          <p:spPr bwMode="auto">
+            <a:xfrm>
+              <a:off x="4860392" y="5616714"/>
+              <a:ext cx="863752" cy="333722"/>
+            </a:xfrm>
+            <a:prstGeom prst="rect">
+              <a:avLst/>
+            </a:prstGeom>
+            <a:extLst>
+              <a:ext uri="{909E8E84-426E-40DD-AFC4-6F175D3DCCD1}">
+                <a14:hiddenFill xmlns:a14="http://schemas.microsoft.com/office/drawing/2010/main">
+                  <a:solidFill>
+                    <a:srgbClr val="FFFFFF"/>
+                  </a:solidFill>
+                </a14:hiddenFill>
+              </a:ext>
+            </a:extLst>
+          </p:spPr>
+        </p:pic>
+        <p:pic>
+          <p:nvPicPr>
+            <p:cNvPr id="1036" name="Picture 12" descr="Home | Data Version Control · DVC">
+              <a:extLst>
+                <a:ext uri="{FF2B5EF4-FFF2-40B4-BE49-F238E27FC236}">
+                  <a16:creationId xmlns:a16="http://schemas.microsoft.com/office/drawing/2014/main" id="{A7820D19-207C-29C7-AC64-D6DAC4D6E167}"/>
+                </a:ext>
+              </a:extLst>
+            </p:cNvPr>
+            <p:cNvPicPr>
+              <a:picLocks noChangeAspect="1" noChangeArrowheads="1"/>
+            </p:cNvPicPr>
+            <p:nvPr/>
+          </p:nvPicPr>
+          <p:blipFill>
+            <a:blip r:embed="rId6" cstate="print">
+              <a:clrChange>
+                <a:clrFrom>
+                  <a:srgbClr val="EEF4F8"/>
+                </a:clrFrom>
+                <a:clrTo>
+                  <a:srgbClr val="EEF4F8">
+                    <a:alpha val="0"/>
+                  </a:srgbClr>
+                </a:clrTo>
+              </a:clrChange>
+              <a:extLst>
+                <a:ext uri="{28A0092B-C50C-407E-A947-70E740481C1C}">
+                  <a14:useLocalDpi xmlns:a14="http://schemas.microsoft.com/office/drawing/2010/main" val="0"/>
+                </a:ext>
+              </a:extLst>
+            </a:blip>
+            <a:srcRect/>
+            <a:stretch>
+              <a:fillRect/>
+            </a:stretch>
+          </p:blipFill>
+          <p:spPr bwMode="auto">
+            <a:xfrm>
+              <a:off x="5665599" y="5442610"/>
+              <a:ext cx="1183257" cy="665582"/>
+            </a:xfrm>
+            <a:prstGeom prst="rect">
+              <a:avLst/>
+            </a:prstGeom>
+            <a:noFill/>
+            <a:extLst>
+              <a:ext uri="{909E8E84-426E-40DD-AFC4-6F175D3DCCD1}">
+                <a14:hiddenFill xmlns:a14="http://schemas.microsoft.com/office/drawing/2010/main">
+                  <a:solidFill>
+                    <a:srgbClr val="FFFFFF"/>
+                  </a:solidFill>
+                </a14:hiddenFill>
+              </a:ext>
+            </a:extLst>
+          </p:spPr>
+        </p:pic>
+      </p:grpSp>
+      <p:pic>
+        <p:nvPicPr>
+          <p:cNvPr id="1026" name="Picture 2" descr="What is DevOps?">
+            <a:extLst>
+              <a:ext uri="{FF2B5EF4-FFF2-40B4-BE49-F238E27FC236}">
+                <a16:creationId xmlns:a16="http://schemas.microsoft.com/office/drawing/2014/main" id="{9FF175FC-4278-2348-E94F-55DB50DB872B}"/>
+              </a:ext>
+            </a:extLst>
+          </p:cNvPr>
+          <p:cNvPicPr>
+            <a:picLocks noChangeAspect="1" noChangeArrowheads="1"/>
+          </p:cNvPicPr>
+          <p:nvPr/>
+        </p:nvPicPr>
+        <p:blipFill>
+          <a:blip r:embed="rId7">
+            <a:extLst>
+              <a:ext uri="{28A0092B-C50C-407E-A947-70E740481C1C}">
+                <a14:useLocalDpi xmlns:a14="http://schemas.microsoft.com/office/drawing/2010/main" val="0"/>
+              </a:ext>
+            </a:extLst>
+          </a:blip>
+          <a:srcRect/>
+          <a:stretch>
+            <a:fillRect/>
+          </a:stretch>
+        </p:blipFill>
+        <p:spPr bwMode="auto">
+          <a:xfrm>
+            <a:off x="2194560" y="932547"/>
+            <a:ext cx="7142152" cy="4017461"/>
           </a:xfrm>
           <a:prstGeom prst="rect">
             <a:avLst/>
           </a:prstGeom>
           <a:noFill/>
-        </p:spPr>
-        <p:txBody>
-          <a:bodyPr wrap="square" lIns="18288" tIns="0" rIns="18288" bIns="0">
-            <a:spAutoFit/>
-          </a:bodyPr>
-          <a:lstStyle/>
-          <a:p>
-            <a:pPr>
-              <a:lnSpc>
-                <a:spcPct val="100000"/>
-              </a:lnSpc>
-              <a:spcAft>
-                <a:spcPts val="400"/>
-              </a:spcAft>
-              <a:defRPr sz="1280">
-                <a:solidFill>
-                  <a:srgbClr val="606874"/>
-                </a:solidFill>
-                <a:latin typeface="Microsoft JhengHei"/>
-              </a:defRPr>
-            </a:pPr>
-            <a:r>
-              <a:t>程式碼掃描</a:t>
-            </a:r>
-          </a:p>
-          <a:p>
-            <a:pPr>
-              <a:lnSpc>
-                <a:spcPct val="100000"/>
-              </a:lnSpc>
-              <a:spcAft>
-                <a:spcPts val="400"/>
-              </a:spcAft>
-              <a:defRPr sz="1280">
-                <a:solidFill>
-                  <a:srgbClr val="606874"/>
-                </a:solidFill>
-                <a:latin typeface="Microsoft JhengHei"/>
-              </a:defRPr>
-            </a:pPr>
-            <a:r>
-              <a:t>品質檢查與 Gate</a:t>
-            </a:r>
-          </a:p>
-        </p:txBody>
-      </p:sp>
-      <p:sp>
-        <p:nvSpPr>
-          <p:cNvPr id="14" name="Rounded Rectangle 13"/>
-          <p:cNvSpPr/>
-          <p:nvPr/>
-        </p:nvSpPr>
-        <p:spPr>
-          <a:xfrm>
-            <a:off x="3401568" y="2084831"/>
-            <a:ext cx="2578608" cy="2331720"/>
-          </a:xfrm>
-          <a:prstGeom prst="roundRect">
-            <a:avLst/>
-          </a:prstGeom>
-          <a:solidFill>
-            <a:srgbClr val="FFFFFF"/>
-          </a:solidFill>
-          <a:ln w="12700">
-            <a:solidFill>
-              <a:srgbClr val="559959"/>
-            </a:solidFill>
-          </a:ln>
-        </p:spPr>
-        <p:style>
-          <a:lnRef idx="1">
-            <a:schemeClr val="accent1"/>
-          </a:lnRef>
-          <a:fillRef idx="3">
-            <a:schemeClr val="accent1"/>
-          </a:fillRef>
-          <a:effectRef idx="2">
-            <a:schemeClr val="accent1"/>
-          </a:effectRef>
-          <a:fontRef idx="minor">
-            <a:schemeClr val="lt1"/>
-          </a:fontRef>
-        </p:style>
-        <p:txBody>
-          <a:bodyPr rtlCol="0" anchor="ctr"/>
-          <a:lstStyle/>
-          <a:p>
-            <a:pPr algn="ctr"/>
-            <a:endParaRPr/>
-          </a:p>
-        </p:txBody>
-      </p:sp>
-      <p:sp>
-        <p:nvSpPr>
-          <p:cNvPr id="15" name="Rounded Rectangle 14"/>
-          <p:cNvSpPr/>
-          <p:nvPr/>
-        </p:nvSpPr>
-        <p:spPr>
-          <a:xfrm>
-            <a:off x="3566160" y="2249424"/>
-            <a:ext cx="749808" cy="292608"/>
-          </a:xfrm>
-          <a:prstGeom prst="roundRect">
-            <a:avLst/>
-          </a:prstGeom>
-          <a:solidFill>
-            <a:srgbClr val="559959"/>
-          </a:solidFill>
-          <a:ln w="12700">
-            <a:solidFill>
-              <a:srgbClr val="559959"/>
-            </a:solidFill>
-          </a:ln>
-        </p:spPr>
-        <p:style>
-          <a:lnRef idx="1">
-            <a:schemeClr val="accent1"/>
-          </a:lnRef>
-          <a:fillRef idx="3">
-            <a:schemeClr val="accent1"/>
-          </a:fillRef>
-          <a:effectRef idx="2">
-            <a:schemeClr val="accent1"/>
-          </a:effectRef>
-          <a:fontRef idx="minor">
-            <a:schemeClr val="lt1"/>
-          </a:fontRef>
-        </p:style>
-        <p:txBody>
-          <a:bodyPr rtlCol="0" anchor="ctr"/>
-          <a:lstStyle/>
-          <a:p>
-            <a:pPr algn="ctr"/>
-            <a:endParaRPr/>
-          </a:p>
-        </p:txBody>
-      </p:sp>
-      <p:sp>
-        <p:nvSpPr>
-          <p:cNvPr id="16" name="TextBox 15"/>
-          <p:cNvSpPr txBox="1"/>
-          <p:nvPr/>
-        </p:nvSpPr>
-        <p:spPr>
-          <a:xfrm>
-            <a:off x="3566160" y="2258568"/>
-            <a:ext cx="749808" cy="256032"/>
-          </a:xfrm>
-          <a:prstGeom prst="rect">
-            <a:avLst/>
-          </a:prstGeom>
-          <a:noFill/>
-        </p:spPr>
-        <p:txBody>
-          <a:bodyPr wrap="square" lIns="9144" tIns="9144" rIns="9144" bIns="9144" anchor="ctr">
-            <a:spAutoFit/>
-          </a:bodyPr>
-          <a:lstStyle/>
-          <a:p>
-            <a:pPr algn="ctr"/>
-            <a:r>
-              <a:rPr sz="1050" b="1">
+          <a:extLst>
+            <a:ext uri="{909E8E84-426E-40DD-AFC4-6F175D3DCCD1}">
+              <a14:hiddenFill xmlns:a14="http://schemas.microsoft.com/office/drawing/2010/main">
                 <a:solidFill>
                   <a:srgbClr val="FFFFFF"/>
                 </a:solidFill>
-                <a:latin typeface="Microsoft JhengHei"/>
-              </a:rPr>
-              <a:t>DEPLOY</a:t>
-            </a:r>
-          </a:p>
-        </p:txBody>
-      </p:sp>
-      <p:sp>
-        <p:nvSpPr>
-          <p:cNvPr id="17" name="TextBox 16"/>
-          <p:cNvSpPr txBox="1"/>
-          <p:nvPr/>
-        </p:nvSpPr>
-        <p:spPr>
-          <a:xfrm>
-            <a:off x="3566160" y="2679191"/>
-            <a:ext cx="2249424" cy="502920"/>
-          </a:xfrm>
-          <a:prstGeom prst="rect">
-            <a:avLst/>
-          </a:prstGeom>
-          <a:noFill/>
-        </p:spPr>
-        <p:txBody>
-          <a:bodyPr wrap="square" lIns="36576" tIns="36576" rIns="36576" bIns="36576" anchor="t">
-            <a:spAutoFit/>
-          </a:bodyPr>
-          <a:lstStyle/>
-          <a:p>
-            <a:pPr algn="l"/>
-            <a:r>
-              <a:rPr sz="1630" b="1">
-                <a:solidFill>
-                  <a:srgbClr val="22262D"/>
-                </a:solidFill>
-                <a:latin typeface="Microsoft JhengHei"/>
-              </a:rPr>
-              <a:t>Ansible × GitLab CD</a:t>
-            </a:r>
-          </a:p>
-        </p:txBody>
-      </p:sp>
-      <p:sp>
-        <p:nvSpPr>
-          <p:cNvPr id="18" name="TextBox 17"/>
-          <p:cNvSpPr txBox="1"/>
-          <p:nvPr/>
-        </p:nvSpPr>
-        <p:spPr>
-          <a:xfrm>
-            <a:off x="3566160" y="3310128"/>
-            <a:ext cx="2231136" cy="777240"/>
-          </a:xfrm>
-          <a:prstGeom prst="rect">
-            <a:avLst/>
-          </a:prstGeom>
-          <a:noFill/>
-        </p:spPr>
-        <p:txBody>
-          <a:bodyPr wrap="square" lIns="18288" tIns="0" rIns="18288" bIns="0">
-            <a:spAutoFit/>
-          </a:bodyPr>
-          <a:lstStyle/>
-          <a:p>
-            <a:pPr>
-              <a:lnSpc>
-                <a:spcPct val="100000"/>
-              </a:lnSpc>
-              <a:spcAft>
-                <a:spcPts val="400"/>
-              </a:spcAft>
-              <a:defRPr sz="1280">
-                <a:solidFill>
-                  <a:srgbClr val="606874"/>
-                </a:solidFill>
-                <a:latin typeface="Microsoft JhengHei"/>
-              </a:defRPr>
-            </a:pPr>
-            <a:r>
-              <a:t>自動化部署</a:t>
-            </a:r>
-          </a:p>
-          <a:p>
-            <a:pPr>
-              <a:lnSpc>
-                <a:spcPct val="100000"/>
-              </a:lnSpc>
-              <a:spcAft>
-                <a:spcPts val="400"/>
-              </a:spcAft>
-              <a:defRPr sz="1280">
-                <a:solidFill>
-                  <a:srgbClr val="606874"/>
-                </a:solidFill>
-                <a:latin typeface="Microsoft JhengHei"/>
-              </a:defRPr>
-            </a:pPr>
-            <a:r>
-              <a:t>環境設定與交付</a:t>
-            </a:r>
-          </a:p>
-        </p:txBody>
-      </p:sp>
-      <p:sp>
-        <p:nvSpPr>
-          <p:cNvPr id="19" name="Rounded Rectangle 18"/>
-          <p:cNvSpPr/>
-          <p:nvPr/>
-        </p:nvSpPr>
-        <p:spPr>
-          <a:xfrm>
-            <a:off x="6144768" y="2084831"/>
-            <a:ext cx="2578608" cy="2331720"/>
-          </a:xfrm>
-          <a:prstGeom prst="roundRect">
-            <a:avLst/>
-          </a:prstGeom>
-          <a:solidFill>
-            <a:srgbClr val="FFFFFF"/>
-          </a:solidFill>
-          <a:ln w="12700">
-            <a:solidFill>
-              <a:srgbClr val="E19135"/>
-            </a:solidFill>
-          </a:ln>
-        </p:spPr>
-        <p:style>
-          <a:lnRef idx="1">
-            <a:schemeClr val="accent1"/>
-          </a:lnRef>
-          <a:fillRef idx="3">
-            <a:schemeClr val="accent1"/>
-          </a:fillRef>
-          <a:effectRef idx="2">
-            <a:schemeClr val="accent1"/>
-          </a:effectRef>
-          <a:fontRef idx="minor">
-            <a:schemeClr val="lt1"/>
-          </a:fontRef>
-        </p:style>
-        <p:txBody>
-          <a:bodyPr rtlCol="0" anchor="ctr"/>
-          <a:lstStyle/>
-          <a:p>
-            <a:pPr algn="ctr"/>
-            <a:endParaRPr/>
-          </a:p>
-        </p:txBody>
-      </p:sp>
-      <p:sp>
-        <p:nvSpPr>
-          <p:cNvPr id="20" name="Rounded Rectangle 19"/>
-          <p:cNvSpPr/>
-          <p:nvPr/>
-        </p:nvSpPr>
-        <p:spPr>
-          <a:xfrm>
-            <a:off x="6309359" y="2249424"/>
-            <a:ext cx="749808" cy="292608"/>
-          </a:xfrm>
-          <a:prstGeom prst="roundRect">
-            <a:avLst/>
-          </a:prstGeom>
-          <a:solidFill>
-            <a:srgbClr val="E19135"/>
-          </a:solidFill>
-          <a:ln w="12700">
-            <a:solidFill>
-              <a:srgbClr val="E19135"/>
-            </a:solidFill>
-          </a:ln>
-        </p:spPr>
-        <p:style>
-          <a:lnRef idx="1">
-            <a:schemeClr val="accent1"/>
-          </a:lnRef>
-          <a:fillRef idx="3">
-            <a:schemeClr val="accent1"/>
-          </a:fillRef>
-          <a:effectRef idx="2">
-            <a:schemeClr val="accent1"/>
-          </a:effectRef>
-          <a:fontRef idx="minor">
-            <a:schemeClr val="lt1"/>
-          </a:fontRef>
-        </p:style>
-        <p:txBody>
-          <a:bodyPr rtlCol="0" anchor="ctr"/>
-          <a:lstStyle/>
-          <a:p>
-            <a:pPr algn="ctr"/>
-            <a:endParaRPr/>
-          </a:p>
-        </p:txBody>
-      </p:sp>
-      <p:sp>
-        <p:nvSpPr>
-          <p:cNvPr id="21" name="TextBox 20"/>
-          <p:cNvSpPr txBox="1"/>
-          <p:nvPr/>
-        </p:nvSpPr>
-        <p:spPr>
-          <a:xfrm>
-            <a:off x="6309359" y="2258568"/>
-            <a:ext cx="749808" cy="256032"/>
-          </a:xfrm>
-          <a:prstGeom prst="rect">
-            <a:avLst/>
-          </a:prstGeom>
-          <a:noFill/>
-        </p:spPr>
-        <p:txBody>
-          <a:bodyPr wrap="square" lIns="9144" tIns="9144" rIns="9144" bIns="9144" anchor="ctr">
-            <a:spAutoFit/>
-          </a:bodyPr>
-          <a:lstStyle/>
-          <a:p>
-            <a:pPr algn="ctr"/>
-            <a:r>
-              <a:rPr sz="1050" b="1">
-                <a:solidFill>
-                  <a:srgbClr val="FFFFFF"/>
-                </a:solidFill>
-                <a:latin typeface="Microsoft JhengHei"/>
-              </a:rPr>
-              <a:t>MONITOR</a:t>
-            </a:r>
-          </a:p>
-        </p:txBody>
-      </p:sp>
-      <p:sp>
-        <p:nvSpPr>
-          <p:cNvPr id="22" name="TextBox 21"/>
-          <p:cNvSpPr txBox="1"/>
-          <p:nvPr/>
-        </p:nvSpPr>
-        <p:spPr>
-          <a:xfrm>
-            <a:off x="6309359" y="2679191"/>
-            <a:ext cx="2249424" cy="502920"/>
-          </a:xfrm>
-          <a:prstGeom prst="rect">
-            <a:avLst/>
-          </a:prstGeom>
-          <a:noFill/>
-        </p:spPr>
-        <p:txBody>
-          <a:bodyPr wrap="square" lIns="36576" tIns="36576" rIns="36576" bIns="36576" anchor="t">
-            <a:spAutoFit/>
-          </a:bodyPr>
-          <a:lstStyle/>
-          <a:p>
-            <a:pPr algn="l"/>
-            <a:r>
-              <a:rPr sz="1630" b="1">
-                <a:solidFill>
-                  <a:srgbClr val="22262D"/>
-                </a:solidFill>
-                <a:latin typeface="Microsoft JhengHei"/>
-              </a:rPr>
-              <a:t>Prometheus / EFK / Thanos</a:t>
-            </a:r>
-          </a:p>
-        </p:txBody>
-      </p:sp>
-      <p:sp>
-        <p:nvSpPr>
-          <p:cNvPr id="23" name="TextBox 22"/>
-          <p:cNvSpPr txBox="1"/>
-          <p:nvPr/>
-        </p:nvSpPr>
-        <p:spPr>
-          <a:xfrm>
-            <a:off x="6309359" y="3310128"/>
-            <a:ext cx="2231136" cy="777240"/>
-          </a:xfrm>
-          <a:prstGeom prst="rect">
-            <a:avLst/>
-          </a:prstGeom>
-          <a:noFill/>
-        </p:spPr>
-        <p:txBody>
-          <a:bodyPr wrap="square" lIns="18288" tIns="0" rIns="18288" bIns="0">
-            <a:spAutoFit/>
-          </a:bodyPr>
-          <a:lstStyle/>
-          <a:p>
-            <a:pPr>
-              <a:lnSpc>
-                <a:spcPct val="100000"/>
-              </a:lnSpc>
-              <a:spcAft>
-                <a:spcPts val="400"/>
-              </a:spcAft>
-              <a:defRPr sz="1280">
-                <a:solidFill>
-                  <a:srgbClr val="606874"/>
-                </a:solidFill>
-                <a:latin typeface="Microsoft JhengHei"/>
-              </a:defRPr>
-            </a:pPr>
-            <a:r>
-              <a:t>指標 + 日誌收集</a:t>
-            </a:r>
-          </a:p>
-          <a:p>
-            <a:pPr>
-              <a:lnSpc>
-                <a:spcPct val="100000"/>
-              </a:lnSpc>
-              <a:spcAft>
-                <a:spcPts val="400"/>
-              </a:spcAft>
-              <a:defRPr sz="1280">
-                <a:solidFill>
-                  <a:srgbClr val="606874"/>
-                </a:solidFill>
-                <a:latin typeface="Microsoft JhengHei"/>
-              </a:defRPr>
-            </a:pPr>
-            <a:r>
-              <a:t>Grafana 戰情室</a:t>
-            </a:r>
-          </a:p>
-        </p:txBody>
-      </p:sp>
-      <p:sp>
-        <p:nvSpPr>
-          <p:cNvPr id="24" name="Rounded Rectangle 23"/>
-          <p:cNvSpPr/>
-          <p:nvPr/>
-        </p:nvSpPr>
-        <p:spPr>
-          <a:xfrm>
-            <a:off x="8887968" y="2084831"/>
-            <a:ext cx="2578608" cy="2331720"/>
-          </a:xfrm>
-          <a:prstGeom prst="roundRect">
-            <a:avLst/>
-          </a:prstGeom>
-          <a:solidFill>
-            <a:srgbClr val="FFFFFF"/>
-          </a:solidFill>
-          <a:ln w="12700">
-            <a:solidFill>
-              <a:srgbClr val="7460C2"/>
-            </a:solidFill>
-          </a:ln>
-        </p:spPr>
-        <p:style>
-          <a:lnRef idx="1">
-            <a:schemeClr val="accent1"/>
-          </a:lnRef>
-          <a:fillRef idx="3">
-            <a:schemeClr val="accent1"/>
-          </a:fillRef>
-          <a:effectRef idx="2">
-            <a:schemeClr val="accent1"/>
-          </a:effectRef>
-          <a:fontRef idx="minor">
-            <a:schemeClr val="lt1"/>
-          </a:fontRef>
-        </p:style>
-        <p:txBody>
-          <a:bodyPr rtlCol="0" anchor="ctr"/>
-          <a:lstStyle/>
-          <a:p>
-            <a:pPr algn="ctr"/>
-            <a:endParaRPr/>
-          </a:p>
-        </p:txBody>
-      </p:sp>
-      <p:sp>
-        <p:nvSpPr>
-          <p:cNvPr id="25" name="Rounded Rectangle 24"/>
-          <p:cNvSpPr/>
-          <p:nvPr/>
-        </p:nvSpPr>
-        <p:spPr>
-          <a:xfrm>
-            <a:off x="9052560" y="2249424"/>
-            <a:ext cx="749808" cy="292608"/>
-          </a:xfrm>
-          <a:prstGeom prst="roundRect">
-            <a:avLst/>
-          </a:prstGeom>
-          <a:solidFill>
-            <a:srgbClr val="7460C2"/>
-          </a:solidFill>
-          <a:ln w="12700">
-            <a:solidFill>
-              <a:srgbClr val="7460C2"/>
-            </a:solidFill>
-          </a:ln>
-        </p:spPr>
-        <p:style>
-          <a:lnRef idx="1">
-            <a:schemeClr val="accent1"/>
-          </a:lnRef>
-          <a:fillRef idx="3">
-            <a:schemeClr val="accent1"/>
-          </a:fillRef>
-          <a:effectRef idx="2">
-            <a:schemeClr val="accent1"/>
-          </a:effectRef>
-          <a:fontRef idx="minor">
-            <a:schemeClr val="lt1"/>
-          </a:fontRef>
-        </p:style>
-        <p:txBody>
-          <a:bodyPr rtlCol="0" anchor="ctr"/>
-          <a:lstStyle/>
-          <a:p>
-            <a:pPr algn="ctr"/>
-            <a:endParaRPr/>
-          </a:p>
-        </p:txBody>
-      </p:sp>
-      <p:sp>
-        <p:nvSpPr>
-          <p:cNvPr id="26" name="TextBox 25"/>
-          <p:cNvSpPr txBox="1"/>
-          <p:nvPr/>
-        </p:nvSpPr>
-        <p:spPr>
-          <a:xfrm>
-            <a:off x="9052560" y="2258568"/>
-            <a:ext cx="749808" cy="256032"/>
-          </a:xfrm>
-          <a:prstGeom prst="rect">
-            <a:avLst/>
-          </a:prstGeom>
-          <a:noFill/>
-        </p:spPr>
-        <p:txBody>
-          <a:bodyPr wrap="square" lIns="9144" tIns="9144" rIns="9144" bIns="9144" anchor="ctr">
-            <a:spAutoFit/>
-          </a:bodyPr>
-          <a:lstStyle/>
-          <a:p>
-            <a:pPr algn="ctr"/>
-            <a:r>
-              <a:rPr sz="1050" b="1">
-                <a:solidFill>
-                  <a:srgbClr val="FFFFFF"/>
-                </a:solidFill>
-                <a:latin typeface="Microsoft JhengHei"/>
-              </a:rPr>
-              <a:t>MLOps</a:t>
-            </a:r>
-          </a:p>
-        </p:txBody>
-      </p:sp>
-      <p:sp>
-        <p:nvSpPr>
-          <p:cNvPr id="27" name="TextBox 26"/>
-          <p:cNvSpPr txBox="1"/>
-          <p:nvPr/>
-        </p:nvSpPr>
-        <p:spPr>
-          <a:xfrm>
-            <a:off x="9052560" y="2679191"/>
-            <a:ext cx="2249424" cy="502920"/>
-          </a:xfrm>
-          <a:prstGeom prst="rect">
-            <a:avLst/>
-          </a:prstGeom>
-          <a:noFill/>
-        </p:spPr>
-        <p:txBody>
-          <a:bodyPr wrap="square" lIns="36576" tIns="36576" rIns="36576" bIns="36576" anchor="t">
-            <a:spAutoFit/>
-          </a:bodyPr>
-          <a:lstStyle/>
-          <a:p>
-            <a:pPr algn="l"/>
-            <a:r>
-              <a:rPr sz="1630" b="1">
-                <a:solidFill>
-                  <a:srgbClr val="22262D"/>
-                </a:solidFill>
-                <a:latin typeface="Microsoft JhengHei"/>
-              </a:rPr>
-              <a:t>MLflow × DVC</a:t>
-            </a:r>
-          </a:p>
-        </p:txBody>
-      </p:sp>
-      <p:sp>
-        <p:nvSpPr>
-          <p:cNvPr id="28" name="TextBox 27"/>
-          <p:cNvSpPr txBox="1"/>
-          <p:nvPr/>
-        </p:nvSpPr>
-        <p:spPr>
-          <a:xfrm>
-            <a:off x="9052560" y="3310128"/>
-            <a:ext cx="2231136" cy="777240"/>
-          </a:xfrm>
-          <a:prstGeom prst="rect">
-            <a:avLst/>
-          </a:prstGeom>
-          <a:noFill/>
-        </p:spPr>
-        <p:txBody>
-          <a:bodyPr wrap="square" lIns="18288" tIns="0" rIns="18288" bIns="0">
-            <a:spAutoFit/>
-          </a:bodyPr>
-          <a:lstStyle/>
-          <a:p>
-            <a:pPr>
-              <a:lnSpc>
-                <a:spcPct val="100000"/>
-              </a:lnSpc>
-              <a:spcAft>
-                <a:spcPts val="400"/>
-              </a:spcAft>
-              <a:defRPr sz="1280">
-                <a:solidFill>
-                  <a:srgbClr val="606874"/>
-                </a:solidFill>
-                <a:latin typeface="Microsoft JhengHei"/>
-              </a:defRPr>
-            </a:pPr>
-            <a:r>
-              <a:t>模型監控</a:t>
-            </a:r>
-          </a:p>
-          <a:p>
-            <a:pPr>
-              <a:lnSpc>
-                <a:spcPct val="100000"/>
-              </a:lnSpc>
-              <a:spcAft>
-                <a:spcPts val="400"/>
-              </a:spcAft>
-              <a:defRPr sz="1280">
-                <a:solidFill>
-                  <a:srgbClr val="606874"/>
-                </a:solidFill>
-                <a:latin typeface="Microsoft JhengHei"/>
-              </a:defRPr>
-            </a:pPr>
-            <a:r>
-              <a:t>資料版本管理</a:t>
-            </a:r>
-          </a:p>
-        </p:txBody>
-      </p:sp>
-      <p:sp>
-        <p:nvSpPr>
-          <p:cNvPr id="29" name="Chevron 28"/>
-          <p:cNvSpPr/>
-          <p:nvPr/>
-        </p:nvSpPr>
-        <p:spPr>
-          <a:xfrm>
-            <a:off x="3246120" y="3044952"/>
-            <a:ext cx="146304" cy="347472"/>
-          </a:xfrm>
-          <a:prstGeom prst="chevron">
-            <a:avLst/>
-          </a:prstGeom>
-          <a:solidFill>
-            <a:srgbClr val="AAB0B8"/>
-          </a:solidFill>
-          <a:ln>
-            <a:noFill/>
-          </a:ln>
-        </p:spPr>
-        <p:style>
-          <a:lnRef idx="1">
-            <a:schemeClr val="accent1"/>
-          </a:lnRef>
-          <a:fillRef idx="3">
-            <a:schemeClr val="accent1"/>
-          </a:fillRef>
-          <a:effectRef idx="2">
-            <a:schemeClr val="accent1"/>
-          </a:effectRef>
-          <a:fontRef idx="minor">
-            <a:schemeClr val="lt1"/>
-          </a:fontRef>
-        </p:style>
-        <p:txBody>
-          <a:bodyPr rtlCol="0" anchor="ctr"/>
-          <a:lstStyle/>
-          <a:p>
-            <a:pPr algn="ctr"/>
-            <a:endParaRPr/>
-          </a:p>
-        </p:txBody>
-      </p:sp>
-      <p:sp>
-        <p:nvSpPr>
-          <p:cNvPr id="30" name="Chevron 29"/>
-          <p:cNvSpPr/>
-          <p:nvPr/>
-        </p:nvSpPr>
-        <p:spPr>
-          <a:xfrm>
-            <a:off x="5989320" y="3044952"/>
-            <a:ext cx="146304" cy="347472"/>
-          </a:xfrm>
-          <a:prstGeom prst="chevron">
-            <a:avLst/>
-          </a:prstGeom>
-          <a:solidFill>
-            <a:srgbClr val="AAB0B8"/>
-          </a:solidFill>
-          <a:ln>
-            <a:noFill/>
-          </a:ln>
-        </p:spPr>
-        <p:style>
-          <a:lnRef idx="1">
-            <a:schemeClr val="accent1"/>
-          </a:lnRef>
-          <a:fillRef idx="3">
-            <a:schemeClr val="accent1"/>
-          </a:fillRef>
-          <a:effectRef idx="2">
-            <a:schemeClr val="accent1"/>
-          </a:effectRef>
-          <a:fontRef idx="minor">
-            <a:schemeClr val="lt1"/>
-          </a:fontRef>
-        </p:style>
-        <p:txBody>
-          <a:bodyPr rtlCol="0" anchor="ctr"/>
-          <a:lstStyle/>
-          <a:p>
-            <a:pPr algn="ctr"/>
-            <a:endParaRPr/>
-          </a:p>
-        </p:txBody>
-      </p:sp>
-      <p:sp>
-        <p:nvSpPr>
-          <p:cNvPr id="31" name="Chevron 30"/>
-          <p:cNvSpPr/>
-          <p:nvPr/>
-        </p:nvSpPr>
-        <p:spPr>
-          <a:xfrm>
-            <a:off x="8732520" y="3044952"/>
-            <a:ext cx="146304" cy="347472"/>
-          </a:xfrm>
-          <a:prstGeom prst="chevron">
-            <a:avLst/>
-          </a:prstGeom>
-          <a:solidFill>
-            <a:srgbClr val="AAB0B8"/>
-          </a:solidFill>
-          <a:ln>
-            <a:noFill/>
-          </a:ln>
-        </p:spPr>
-        <p:style>
-          <a:lnRef idx="1">
-            <a:schemeClr val="accent1"/>
-          </a:lnRef>
-          <a:fillRef idx="3">
-            <a:schemeClr val="accent1"/>
-          </a:fillRef>
-          <a:effectRef idx="2">
-            <a:schemeClr val="accent1"/>
-          </a:effectRef>
-          <a:fontRef idx="minor">
-            <a:schemeClr val="lt1"/>
-          </a:fontRef>
-        </p:style>
-        <p:txBody>
-          <a:bodyPr rtlCol="0" anchor="ctr"/>
-          <a:lstStyle/>
-          <a:p>
-            <a:pPr algn="ctr"/>
-            <a:endParaRPr/>
-          </a:p>
-        </p:txBody>
-      </p:sp>
-      <p:sp>
-        <p:nvSpPr>
-          <p:cNvPr id="32" name="Rounded Rectangle 31"/>
-          <p:cNvSpPr/>
-          <p:nvPr/>
-        </p:nvSpPr>
-        <p:spPr>
-          <a:xfrm>
-            <a:off x="6291072" y="3767328"/>
-            <a:ext cx="2267712" cy="384048"/>
-          </a:xfrm>
-          <a:prstGeom prst="roundRect">
-            <a:avLst/>
-          </a:prstGeom>
-          <a:solidFill>
-            <a:srgbClr val="FFF8EE"/>
-          </a:solidFill>
-          <a:ln w="12700">
-            <a:solidFill>
-              <a:srgbClr val="FFF8EE"/>
-            </a:solidFill>
-          </a:ln>
-        </p:spPr>
-        <p:style>
-          <a:lnRef idx="1">
-            <a:schemeClr val="accent1"/>
-          </a:lnRef>
-          <a:fillRef idx="3">
-            <a:schemeClr val="accent1"/>
-          </a:fillRef>
-          <a:effectRef idx="2">
-            <a:schemeClr val="accent1"/>
-          </a:effectRef>
-          <a:fontRef idx="minor">
-            <a:schemeClr val="lt1"/>
-          </a:fontRef>
-        </p:style>
-        <p:txBody>
-          <a:bodyPr rtlCol="0" anchor="ctr"/>
-          <a:lstStyle/>
-          <a:p>
-            <a:pPr algn="ctr"/>
-            <a:endParaRPr/>
-          </a:p>
-        </p:txBody>
-      </p:sp>
-      <p:sp>
-        <p:nvSpPr>
-          <p:cNvPr id="33" name="TextBox 32"/>
-          <p:cNvSpPr txBox="1"/>
-          <p:nvPr/>
-        </p:nvSpPr>
-        <p:spPr>
-          <a:xfrm>
-            <a:off x="6336792" y="3831336"/>
-            <a:ext cx="2167128" cy="182880"/>
-          </a:xfrm>
-          <a:prstGeom prst="rect">
-            <a:avLst/>
-          </a:prstGeom>
-          <a:noFill/>
-        </p:spPr>
-        <p:txBody>
-          <a:bodyPr wrap="square" lIns="36576" tIns="36576" rIns="36576" bIns="36576" anchor="t">
-            <a:spAutoFit/>
-          </a:bodyPr>
-          <a:lstStyle/>
-          <a:p>
-            <a:pPr algn="ctr"/>
-            <a:r>
-              <a:rPr sz="930" b="1">
-                <a:solidFill>
-                  <a:srgbClr val="E19135"/>
-                </a:solidFill>
-                <a:latin typeface="Microsoft JhengHei"/>
-              </a:rPr>
-              <a:t>Host → Prom/EFK → Thanos → Grafana</a:t>
-            </a:r>
-          </a:p>
-        </p:txBody>
-      </p:sp>
-      <p:sp>
-        <p:nvSpPr>
-          <p:cNvPr id="34" name="Rounded Rectangle 33"/>
-          <p:cNvSpPr/>
-          <p:nvPr/>
-        </p:nvSpPr>
-        <p:spPr>
-          <a:xfrm>
-            <a:off x="658368" y="4681728"/>
-            <a:ext cx="10863072" cy="1133856"/>
-          </a:xfrm>
-          <a:prstGeom prst="roundRect">
-            <a:avLst/>
-          </a:prstGeom>
-          <a:solidFill>
-            <a:srgbClr val="F8FAFD"/>
-          </a:solidFill>
-          <a:ln w="12700">
-            <a:solidFill>
-              <a:srgbClr val="D6DDE7"/>
-            </a:solidFill>
-          </a:ln>
-        </p:spPr>
-        <p:style>
-          <a:lnRef idx="1">
-            <a:schemeClr val="accent1"/>
-          </a:lnRef>
-          <a:fillRef idx="3">
-            <a:schemeClr val="accent1"/>
-          </a:fillRef>
-          <a:effectRef idx="2">
-            <a:schemeClr val="accent1"/>
-          </a:effectRef>
-          <a:fontRef idx="minor">
-            <a:schemeClr val="lt1"/>
-          </a:fontRef>
-        </p:style>
-        <p:txBody>
-          <a:bodyPr rtlCol="0" anchor="ctr"/>
-          <a:lstStyle/>
-          <a:p>
-            <a:pPr algn="ctr"/>
-            <a:endParaRPr/>
-          </a:p>
-        </p:txBody>
-      </p:sp>
-      <p:sp>
-        <p:nvSpPr>
-          <p:cNvPr id="35" name="TextBox 34"/>
-          <p:cNvSpPr txBox="1"/>
-          <p:nvPr/>
-        </p:nvSpPr>
-        <p:spPr>
-          <a:xfrm>
-            <a:off x="868680" y="4882896"/>
-            <a:ext cx="2057400" cy="274320"/>
-          </a:xfrm>
-          <a:prstGeom prst="rect">
-            <a:avLst/>
-          </a:prstGeom>
-          <a:noFill/>
-        </p:spPr>
-        <p:txBody>
-          <a:bodyPr wrap="square" lIns="36576" tIns="36576" rIns="36576" bIns="36576" anchor="t">
-            <a:spAutoFit/>
-          </a:bodyPr>
-          <a:lstStyle/>
-          <a:p>
-            <a:pPr algn="l"/>
-            <a:r>
-              <a:rPr sz="1550" b="1">
-                <a:solidFill>
-                  <a:srgbClr val="295BAA"/>
-                </a:solidFill>
-                <a:latin typeface="Microsoft JhengHei"/>
-              </a:rPr>
-              <a:t>平台導入 / 延伸</a:t>
-            </a:r>
-          </a:p>
-        </p:txBody>
-      </p:sp>
-      <p:sp>
-        <p:nvSpPr>
-          <p:cNvPr id="36" name="TextBox 35"/>
-          <p:cNvSpPr txBox="1"/>
-          <p:nvPr/>
-        </p:nvSpPr>
-        <p:spPr>
-          <a:xfrm>
-            <a:off x="2788920" y="4846320"/>
-            <a:ext cx="3840480" cy="420624"/>
-          </a:xfrm>
-          <a:prstGeom prst="rect">
-            <a:avLst/>
-          </a:prstGeom>
-          <a:noFill/>
-        </p:spPr>
-        <p:txBody>
-          <a:bodyPr wrap="square" lIns="36576" tIns="36576" rIns="36576" bIns="36576" anchor="t">
-            <a:spAutoFit/>
-          </a:bodyPr>
-          <a:lstStyle/>
-          <a:p>
-            <a:pPr algn="l"/>
-            <a:r>
-              <a:rPr sz="1320" b="1">
-                <a:solidFill>
-                  <a:srgbClr val="22262D"/>
-                </a:solidFill>
-                <a:latin typeface="Microsoft JhengHei"/>
-              </a:rPr>
-              <a:t>智能排程應用課：CI/CD Pipeline 設計
-Grafana 硬體資源監控儀表板</a:t>
-            </a:r>
-          </a:p>
-        </p:txBody>
-      </p:sp>
-      <p:sp>
-        <p:nvSpPr>
-          <p:cNvPr id="37" name="TextBox 36"/>
-          <p:cNvSpPr txBox="1"/>
-          <p:nvPr/>
-        </p:nvSpPr>
-        <p:spPr>
-          <a:xfrm>
-            <a:off x="7059168" y="4846320"/>
-            <a:ext cx="3931920" cy="420624"/>
-          </a:xfrm>
-          <a:prstGeom prst="rect">
-            <a:avLst/>
-          </a:prstGeom>
-          <a:noFill/>
-        </p:spPr>
-        <p:txBody>
-          <a:bodyPr wrap="square" lIns="36576" tIns="36576" rIns="36576" bIns="36576" anchor="t">
-            <a:spAutoFit/>
-          </a:bodyPr>
-          <a:lstStyle/>
-          <a:p>
-            <a:pPr algn="l"/>
-            <a:r>
-              <a:rPr sz="1320" b="1">
-                <a:solidFill>
-                  <a:srgbClr val="22262D"/>
-                </a:solidFill>
-                <a:latin typeface="Microsoft JhengHei"/>
-              </a:rPr>
-              <a:t>VictoriaMetrics Cluster
-作為監控平台擴充與長期維運方案</a:t>
-            </a:r>
-          </a:p>
-        </p:txBody>
-      </p:sp>
-      <p:sp>
-        <p:nvSpPr>
-          <p:cNvPr id="38" name="Rectangle 37"/>
-          <p:cNvSpPr/>
-          <p:nvPr/>
-        </p:nvSpPr>
-        <p:spPr>
-          <a:xfrm>
-            <a:off x="6839712" y="4855464"/>
-            <a:ext cx="9144" cy="694944"/>
-          </a:xfrm>
-          <a:prstGeom prst="rect">
-            <a:avLst/>
-          </a:prstGeom>
-          <a:solidFill>
-            <a:srgbClr val="D6DDE7"/>
-          </a:solidFill>
-          <a:ln>
-            <a:noFill/>
-          </a:ln>
-        </p:spPr>
-        <p:style>
-          <a:lnRef idx="1">
-            <a:schemeClr val="accent1"/>
-          </a:lnRef>
-          <a:fillRef idx="3">
-            <a:schemeClr val="accent1"/>
-          </a:fillRef>
-          <a:effectRef idx="2">
-            <a:schemeClr val="accent1"/>
-          </a:effectRef>
-          <a:fontRef idx="minor">
-            <a:schemeClr val="lt1"/>
-          </a:fontRef>
-        </p:style>
-        <p:txBody>
-          <a:bodyPr rtlCol="0" anchor="ctr"/>
-          <a:lstStyle/>
-          <a:p>
-            <a:pPr algn="ctr"/>
-            <a:endParaRPr/>
-          </a:p>
-        </p:txBody>
-      </p:sp>
-      <p:sp>
-        <p:nvSpPr>
-          <p:cNvPr id="39" name="TextBox 38"/>
-          <p:cNvSpPr txBox="1"/>
-          <p:nvPr/>
-        </p:nvSpPr>
-        <p:spPr>
-          <a:xfrm>
-            <a:off x="658368" y="6510528"/>
-            <a:ext cx="3200400" cy="146304"/>
-          </a:xfrm>
-          <a:prstGeom prst="rect">
-            <a:avLst/>
-          </a:prstGeom>
-          <a:noFill/>
-        </p:spPr>
-        <p:txBody>
-          <a:bodyPr wrap="square" lIns="36576" tIns="36576" rIns="36576" bIns="36576" anchor="t">
-            <a:spAutoFit/>
-          </a:bodyPr>
-          <a:lstStyle/>
-          <a:p>
-            <a:pPr algn="l"/>
-            <a:r>
-              <a:rPr sz="720" b="0">
-                <a:solidFill>
-                  <a:srgbClr val="A0A6AF"/>
-                </a:solidFill>
-                <a:latin typeface="Microsoft JhengHei"/>
-              </a:rPr>
-              <a:t>AI × SYSTEM × CLOUD</a:t>
-            </a:r>
-          </a:p>
-        </p:txBody>
-      </p:sp>
-      <p:sp>
-        <p:nvSpPr>
-          <p:cNvPr id="40" name="TextBox 39"/>
-          <p:cNvSpPr txBox="1"/>
-          <p:nvPr/>
-        </p:nvSpPr>
-        <p:spPr>
-          <a:xfrm>
-            <a:off x="11045952" y="6473952"/>
-            <a:ext cx="411480" cy="182880"/>
-          </a:xfrm>
-          <a:prstGeom prst="rect">
-            <a:avLst/>
-          </a:prstGeom>
-          <a:noFill/>
-        </p:spPr>
-        <p:txBody>
-          <a:bodyPr wrap="square" lIns="36576" tIns="36576" rIns="36576" bIns="36576" anchor="t">
-            <a:spAutoFit/>
-          </a:bodyPr>
-          <a:lstStyle/>
-          <a:p>
-            <a:pPr algn="ctr"/>
-            <a:r>
-              <a:rPr sz="850" b="0">
-                <a:solidFill>
-                  <a:srgbClr val="969CA5"/>
-                </a:solidFill>
-                <a:latin typeface="Microsoft JhengHei"/>
-              </a:rPr>
-              <a:t>07</a:t>
-            </a:r>
-          </a:p>
-        </p:txBody>
-      </p:sp>
+              </a14:hiddenFill>
+            </a:ext>
+          </a:extLst>
+        </p:spPr>
+      </p:pic>
     </p:spTree>
+    <p:extLst>
+      <p:ext uri="{BB962C8B-B14F-4D97-AF65-F5344CB8AC3E}">
+        <p14:creationId xmlns:p14="http://schemas.microsoft.com/office/powerpoint/2010/main" val="2592980839"/>
+      </p:ext>
+    </p:extLst>
   </p:cSld>
   <p:clrMapOvr>
     <a:masterClrMapping/>

</xml_diff>